<commit_message>
docs: add more user task examples to slides
User prompt:
can you add more user task examples in the slides
</commit_message>
<xml_diff>
--- a/papers/sekisssorcar/se_kiss_sorcar_slides.pptx
+++ b/papers/sekisssorcar/se_kiss_sorcar_slides.pptx
@@ -19,6 +19,8 @@
     <p:sldId id="267" r:id="rId18"/>
     <p:sldId id="268" r:id="rId19"/>
     <p:sldId id="269" r:id="rId20"/>
+    <p:sldId id="278" r:id="rId29"/>
+    <p:sldId id="279" r:id="rId30"/>
     <p:sldId id="270" r:id="rId21"/>
     <p:sldId id="271" r:id="rId22"/>
     <p:sldId id="272" r:id="rId23"/>
@@ -6711,7 +6713,7 @@
                 </a:solidFill>
                 <a:latin typeface="Arial"/>
               </a:rPr>
-              <a:t>15</a:t>
+              <a:t>17</a:t>
             </a:r>
           </a:p>
         </p:txBody>
@@ -7947,7 +7949,7 @@
                 </a:solidFill>
                 <a:latin typeface="Arial"/>
               </a:rPr>
-              <a:t>16</a:t>
+              <a:t>18</a:t>
             </a:r>
           </a:p>
         </p:txBody>
@@ -9542,7 +9544,7 @@
                 </a:solidFill>
                 <a:latin typeface="Arial"/>
               </a:rPr>
-              <a:t>17</a:t>
+              <a:t>19</a:t>
             </a:r>
           </a:p>
         </p:txBody>
@@ -10324,7 +10326,7 @@
                 </a:solidFill>
                 <a:latin typeface="Arial"/>
               </a:rPr>
-              <a:t>18</a:t>
+              <a:t>20</a:t>
             </a:r>
           </a:p>
         </p:txBody>
@@ -10826,7 +10828,7 @@
                 </a:solidFill>
                 <a:latin typeface="Arial"/>
               </a:rPr>
-              <a:t>19</a:t>
+              <a:t>21</a:t>
             </a:r>
           </a:p>
         </p:txBody>
@@ -11842,7 +11844,7 @@
                 </a:solidFill>
                 <a:latin typeface="Arial"/>
               </a:rPr>
-              <a:t>20</a:t>
+              <a:t>22</a:t>
             </a:r>
           </a:p>
         </p:txBody>
@@ -12376,7 +12378,7 @@
                 </a:solidFill>
                 <a:latin typeface="Arial"/>
               </a:rPr>
-              <a:t>21</a:t>
+              <a:t>23</a:t>
             </a:r>
           </a:p>
         </p:txBody>
@@ -12625,6 +12627,2874 @@
                 <a:latin typeface="Arial"/>
               </a:rPr>
               <a:t>github.com/ksenxx/kiss_ai</a:t>
+            </a:r>
+          </a:p>
+        </p:txBody>
+      </p:sp>
+    </p:spTree>
+  </p:cSld>
+  <p:clrMapOvr>
+    <a:masterClrMapping/>
+  </p:clrMapOvr>
+</p:sld>
+</file>
+
+<file path=ppt/slides/slide23.xml><?xml version="1.0" encoding="utf-8"?>
+<p:sld xmlns:a="http://schemas.openxmlformats.org/drawingml/2006/main" xmlns:p="http://schemas.openxmlformats.org/presentationml/2006/main" xmlns:r="http://schemas.openxmlformats.org/officeDocument/2006/relationships">
+  <p:cSld>
+    <p:bg>
+      <p:bgPr>
+        <a:solidFill>
+          <a:srgbClr val="F7F5EF"/>
+        </a:solidFill>
+        <a:effectLst/>
+      </p:bgPr>
+    </p:bg>
+    <p:spTree>
+      <p:nvGrpSpPr>
+        <p:cNvPr id="1" name=""/>
+        <p:cNvGrpSpPr/>
+        <p:nvPr/>
+      </p:nvGrpSpPr>
+      <p:grpSpPr/>
+      <p:sp>
+        <p:nvSpPr>
+          <p:cNvPr id="2" name="Rectangle 1"/>
+          <p:cNvSpPr/>
+          <p:nvPr/>
+        </p:nvSpPr>
+        <p:spPr>
+          <a:xfrm>
+            <a:off x="457200" y="914400"/>
+            <a:ext cx="146304" cy="502920"/>
+          </a:xfrm>
+          <a:prstGeom prst="rect">
+            <a:avLst/>
+          </a:prstGeom>
+          <a:solidFill>
+            <a:srgbClr val="FDB515"/>
+          </a:solidFill>
+          <a:ln>
+            <a:noFill/>
+          </a:ln>
+          <a:effectLst/>
+        </p:spPr>
+        <p:style>
+          <a:lnRef idx="1">
+            <a:schemeClr val="accent1"/>
+          </a:lnRef>
+          <a:fillRef idx="3">
+            <a:schemeClr val="accent1"/>
+          </a:fillRef>
+          <a:effectRef idx="2">
+            <a:schemeClr val="accent1"/>
+          </a:effectRef>
+          <a:fontRef idx="minor">
+            <a:schemeClr val="lt1"/>
+          </a:fontRef>
+        </p:style>
+        <p:txBody>
+          <a:bodyPr rtlCol="0" anchor="ctr"/>
+          <a:lstStyle/>
+          <a:p>
+            <a:pPr algn="ctr"/>
+          </a:p>
+        </p:txBody>
+      </p:sp>
+      <p:sp>
+        <p:nvSpPr>
+          <p:cNvPr id="3" name="TextBox 2"/>
+          <p:cNvSpPr txBox="1"/>
+          <p:nvPr/>
+        </p:nvSpPr>
+        <p:spPr>
+          <a:xfrm>
+            <a:off x="822960" y="502920"/>
+            <a:ext cx="10515600" cy="365760"/>
+          </a:xfrm>
+          <a:prstGeom prst="rect">
+            <a:avLst/>
+          </a:prstGeom>
+          <a:noFill/>
+        </p:spPr>
+        <p:txBody>
+          <a:bodyPr wrap="square" anchor="t" lIns="0" rIns="0" tIns="0" bIns="0">
+            <a:spAutoFit/>
+          </a:bodyPr>
+          <a:lstStyle/>
+          <a:p>
+            <a:r>
+              <a:rPr sz="1300" b="1" i="0">
+                <a:solidFill>
+                  <a:srgbClr val="C88A00"/>
+                </a:solidFill>
+                <a:latin typeface="Arial"/>
+              </a:rPr>
+              <a:t>F  R  O  M      T  H  E      L  O  G</a:t>
+            </a:r>
+          </a:p>
+        </p:txBody>
+      </p:sp>
+      <p:sp>
+        <p:nvSpPr>
+          <p:cNvPr id="4" name="TextBox 3"/>
+          <p:cNvSpPr txBox="1"/>
+          <p:nvPr/>
+        </p:nvSpPr>
+        <p:spPr>
+          <a:xfrm>
+            <a:off x="822960" y="868680"/>
+            <a:ext cx="10515600" cy="1280160"/>
+          </a:xfrm>
+          <a:prstGeom prst="rect">
+            <a:avLst/>
+          </a:prstGeom>
+          <a:noFill/>
+        </p:spPr>
+        <p:txBody>
+          <a:bodyPr wrap="square" anchor="t" lIns="0" rIns="0" tIns="0" bIns="0">
+            <a:spAutoFit/>
+          </a:bodyPr>
+          <a:lstStyle/>
+          <a:p>
+            <a:r>
+              <a:rPr sz="3400" b="1" i="0">
+                <a:solidFill>
+                  <a:srgbClr val="003262"/>
+                </a:solidFill>
+                <a:latin typeface="Arial"/>
+              </a:rPr>
+              <a:t>Verbatim user tasks — engineering</a:t>
+            </a:r>
+          </a:p>
+        </p:txBody>
+      </p:sp>
+      <p:sp>
+        <p:nvSpPr>
+          <p:cNvPr id="5" name="TextBox 4"/>
+          <p:cNvSpPr txBox="1"/>
+          <p:nvPr/>
+        </p:nvSpPr>
+        <p:spPr>
+          <a:xfrm>
+            <a:off x="822960" y="1783080"/>
+            <a:ext cx="10607040" cy="502920"/>
+          </a:xfrm>
+          <a:prstGeom prst="rect">
+            <a:avLst/>
+          </a:prstGeom>
+          <a:noFill/>
+        </p:spPr>
+        <p:txBody>
+          <a:bodyPr wrap="square" anchor="t" lIns="0" rIns="0" tIns="0" bIns="0">
+            <a:spAutoFit/>
+          </a:bodyPr>
+          <a:lstStyle/>
+          <a:p>
+            <a:pPr>
+              <a:lnSpc>
+                <a:spcPct val="112000"/>
+              </a:lnSpc>
+            </a:pPr>
+            <a:r>
+              <a:rPr sz="2100" b="0" i="0">
+                <a:solidFill>
+                  <a:srgbClr val="4A5260"/>
+                </a:solidFill>
+                <a:latin typeface="Arial"/>
+              </a:rPr>
+              <a:t>Real, unedited requests recorded in sorcar.db — short natural language, one task at a time.</a:t>
+            </a:r>
+          </a:p>
+        </p:txBody>
+      </p:sp>
+      <p:sp>
+        <p:nvSpPr>
+          <p:cNvPr id="6" name="Rectangle 5"/>
+          <p:cNvSpPr/>
+          <p:nvPr/>
+        </p:nvSpPr>
+        <p:spPr>
+          <a:xfrm>
+            <a:off x="822960" y="2377440"/>
+            <a:ext cx="5166360" cy="914400"/>
+          </a:xfrm>
+          <a:prstGeom prst="rect">
+            <a:avLst/>
+          </a:prstGeom>
+          <a:solidFill>
+            <a:srgbClr val="003262"/>
+          </a:solidFill>
+          <a:ln>
+            <a:noFill/>
+          </a:ln>
+          <a:effectLst/>
+        </p:spPr>
+        <p:style>
+          <a:lnRef idx="1">
+            <a:schemeClr val="accent1"/>
+          </a:lnRef>
+          <a:fillRef idx="3">
+            <a:schemeClr val="accent1"/>
+          </a:fillRef>
+          <a:effectRef idx="2">
+            <a:schemeClr val="accent1"/>
+          </a:effectRef>
+          <a:fontRef idx="minor">
+            <a:schemeClr val="lt1"/>
+          </a:fontRef>
+        </p:style>
+        <p:txBody>
+          <a:bodyPr rtlCol="0" anchor="ctr"/>
+          <a:lstStyle/>
+          <a:p>
+            <a:pPr algn="ctr"/>
+          </a:p>
+        </p:txBody>
+      </p:sp>
+      <p:sp>
+        <p:nvSpPr>
+          <p:cNvPr id="7" name="Rectangle 6"/>
+          <p:cNvSpPr/>
+          <p:nvPr/>
+        </p:nvSpPr>
+        <p:spPr>
+          <a:xfrm>
+            <a:off x="822960" y="2377440"/>
+            <a:ext cx="5166360" cy="91440"/>
+          </a:xfrm>
+          <a:prstGeom prst="rect">
+            <a:avLst/>
+          </a:prstGeom>
+          <a:solidFill>
+            <a:srgbClr val="FDB515"/>
+          </a:solidFill>
+          <a:ln>
+            <a:noFill/>
+          </a:ln>
+          <a:effectLst/>
+        </p:spPr>
+        <p:style>
+          <a:lnRef idx="1">
+            <a:schemeClr val="accent1"/>
+          </a:lnRef>
+          <a:fillRef idx="3">
+            <a:schemeClr val="accent1"/>
+          </a:fillRef>
+          <a:effectRef idx="2">
+            <a:schemeClr val="accent1"/>
+          </a:effectRef>
+          <a:fontRef idx="minor">
+            <a:schemeClr val="lt1"/>
+          </a:fontRef>
+        </p:style>
+        <p:txBody>
+          <a:bodyPr rtlCol="0" anchor="ctr"/>
+          <a:lstStyle/>
+          <a:p>
+            <a:pPr algn="ctr"/>
+          </a:p>
+        </p:txBody>
+      </p:sp>
+      <p:sp>
+        <p:nvSpPr>
+          <p:cNvPr id="8" name="TextBox 7"/>
+          <p:cNvSpPr txBox="1"/>
+          <p:nvPr/>
+        </p:nvSpPr>
+        <p:spPr>
+          <a:xfrm>
+            <a:off x="1097280" y="2578608"/>
+            <a:ext cx="4617720" cy="603503"/>
+          </a:xfrm>
+          <a:prstGeom prst="rect">
+            <a:avLst/>
+          </a:prstGeom>
+          <a:noFill/>
+        </p:spPr>
+        <p:txBody>
+          <a:bodyPr wrap="square" anchor="ctr" lIns="0" rIns="0" tIns="0" bIns="0">
+            <a:spAutoFit/>
+          </a:bodyPr>
+          <a:lstStyle/>
+          <a:p>
+            <a:pPr>
+              <a:spcAft>
+                <a:spcPts val="600"/>
+              </a:spcAft>
+            </a:pPr>
+            <a:r>
+              <a:rPr sz="1200" b="1" i="0">
+                <a:solidFill>
+                  <a:srgbClr val="FDB515"/>
+                </a:solidFill>
+                <a:latin typeface="Arial"/>
+              </a:rPr>
+              <a:t>TEST-FIRST BUG FIX</a:t>
+            </a:r>
+          </a:p>
+          <a:p>
+            <a:pPr>
+              <a:lnSpc>
+                <a:spcPct val="110000"/>
+              </a:lnSpc>
+            </a:pPr>
+            <a:r>
+              <a:rPr sz="1450" b="0" i="1">
+                <a:solidFill>
+                  <a:srgbClr val="FFFFFF"/>
+                </a:solidFill>
+                <a:latin typeface="Arial"/>
+              </a:rPr>
+              <a:t>“Can you reproduce the bug by writing an integration test? Then fix it.”</a:t>
+            </a:r>
+          </a:p>
+        </p:txBody>
+      </p:sp>
+      <p:sp>
+        <p:nvSpPr>
+          <p:cNvPr id="9" name="Rectangle 8"/>
+          <p:cNvSpPr/>
+          <p:nvPr/>
+        </p:nvSpPr>
+        <p:spPr>
+          <a:xfrm>
+            <a:off x="6172200" y="2377440"/>
+            <a:ext cx="5166360" cy="914400"/>
+          </a:xfrm>
+          <a:prstGeom prst="rect">
+            <a:avLst/>
+          </a:prstGeom>
+          <a:solidFill>
+            <a:srgbClr val="003262"/>
+          </a:solidFill>
+          <a:ln>
+            <a:noFill/>
+          </a:ln>
+          <a:effectLst/>
+        </p:spPr>
+        <p:style>
+          <a:lnRef idx="1">
+            <a:schemeClr val="accent1"/>
+          </a:lnRef>
+          <a:fillRef idx="3">
+            <a:schemeClr val="accent1"/>
+          </a:fillRef>
+          <a:effectRef idx="2">
+            <a:schemeClr val="accent1"/>
+          </a:effectRef>
+          <a:fontRef idx="minor">
+            <a:schemeClr val="lt1"/>
+          </a:fontRef>
+        </p:style>
+        <p:txBody>
+          <a:bodyPr rtlCol="0" anchor="ctr"/>
+          <a:lstStyle/>
+          <a:p>
+            <a:pPr algn="ctr"/>
+          </a:p>
+        </p:txBody>
+      </p:sp>
+      <p:sp>
+        <p:nvSpPr>
+          <p:cNvPr id="10" name="Rectangle 9"/>
+          <p:cNvSpPr/>
+          <p:nvPr/>
+        </p:nvSpPr>
+        <p:spPr>
+          <a:xfrm>
+            <a:off x="6172200" y="2377440"/>
+            <a:ext cx="5166360" cy="91440"/>
+          </a:xfrm>
+          <a:prstGeom prst="rect">
+            <a:avLst/>
+          </a:prstGeom>
+          <a:solidFill>
+            <a:srgbClr val="FDB515"/>
+          </a:solidFill>
+          <a:ln>
+            <a:noFill/>
+          </a:ln>
+          <a:effectLst/>
+        </p:spPr>
+        <p:style>
+          <a:lnRef idx="1">
+            <a:schemeClr val="accent1"/>
+          </a:lnRef>
+          <a:fillRef idx="3">
+            <a:schemeClr val="accent1"/>
+          </a:fillRef>
+          <a:effectRef idx="2">
+            <a:schemeClr val="accent1"/>
+          </a:effectRef>
+          <a:fontRef idx="minor">
+            <a:schemeClr val="lt1"/>
+          </a:fontRef>
+        </p:style>
+        <p:txBody>
+          <a:bodyPr rtlCol="0" anchor="ctr"/>
+          <a:lstStyle/>
+          <a:p>
+            <a:pPr algn="ctr"/>
+          </a:p>
+        </p:txBody>
+      </p:sp>
+      <p:sp>
+        <p:nvSpPr>
+          <p:cNvPr id="11" name="TextBox 10"/>
+          <p:cNvSpPr txBox="1"/>
+          <p:nvPr/>
+        </p:nvSpPr>
+        <p:spPr>
+          <a:xfrm>
+            <a:off x="6446520" y="2578608"/>
+            <a:ext cx="4617720" cy="603503"/>
+          </a:xfrm>
+          <a:prstGeom prst="rect">
+            <a:avLst/>
+          </a:prstGeom>
+          <a:noFill/>
+        </p:spPr>
+        <p:txBody>
+          <a:bodyPr wrap="square" anchor="ctr" lIns="0" rIns="0" tIns="0" bIns="0">
+            <a:spAutoFit/>
+          </a:bodyPr>
+          <a:lstStyle/>
+          <a:p>
+            <a:pPr>
+              <a:spcAft>
+                <a:spcPts val="600"/>
+              </a:spcAft>
+            </a:pPr>
+            <a:r>
+              <a:rPr sz="1200" b="1" i="0">
+                <a:solidFill>
+                  <a:srgbClr val="FDB515"/>
+                </a:solidFill>
+                <a:latin typeface="Arial"/>
+              </a:rPr>
+              <a:t>BUG REPORT</a:t>
+            </a:r>
+          </a:p>
+          <a:p>
+            <a:pPr>
+              <a:lnSpc>
+                <a:spcPct val="110000"/>
+              </a:lnSpc>
+            </a:pPr>
+            <a:r>
+              <a:rPr sz="1450" b="0" i="1">
+                <a:solidFill>
+                  <a:srgbClr val="FFFFFF"/>
+                </a:solidFill>
+                <a:latin typeface="Arial"/>
+              </a:rPr>
+              <a:t>“ask_user_question is not showing its window in the web/mobile app.”</a:t>
+            </a:r>
+          </a:p>
+        </p:txBody>
+      </p:sp>
+      <p:sp>
+        <p:nvSpPr>
+          <p:cNvPr id="12" name="Rectangle 11"/>
+          <p:cNvSpPr/>
+          <p:nvPr/>
+        </p:nvSpPr>
+        <p:spPr>
+          <a:xfrm>
+            <a:off x="822960" y="3415284"/>
+            <a:ext cx="5166360" cy="914400"/>
+          </a:xfrm>
+          <a:prstGeom prst="rect">
+            <a:avLst/>
+          </a:prstGeom>
+          <a:solidFill>
+            <a:srgbClr val="003262"/>
+          </a:solidFill>
+          <a:ln>
+            <a:noFill/>
+          </a:ln>
+          <a:effectLst/>
+        </p:spPr>
+        <p:style>
+          <a:lnRef idx="1">
+            <a:schemeClr val="accent1"/>
+          </a:lnRef>
+          <a:fillRef idx="3">
+            <a:schemeClr val="accent1"/>
+          </a:fillRef>
+          <a:effectRef idx="2">
+            <a:schemeClr val="accent1"/>
+          </a:effectRef>
+          <a:fontRef idx="minor">
+            <a:schemeClr val="lt1"/>
+          </a:fontRef>
+        </p:style>
+        <p:txBody>
+          <a:bodyPr rtlCol="0" anchor="ctr"/>
+          <a:lstStyle/>
+          <a:p>
+            <a:pPr algn="ctr"/>
+          </a:p>
+        </p:txBody>
+      </p:sp>
+      <p:sp>
+        <p:nvSpPr>
+          <p:cNvPr id="13" name="Rectangle 12"/>
+          <p:cNvSpPr/>
+          <p:nvPr/>
+        </p:nvSpPr>
+        <p:spPr>
+          <a:xfrm>
+            <a:off x="822960" y="3415284"/>
+            <a:ext cx="5166360" cy="91440"/>
+          </a:xfrm>
+          <a:prstGeom prst="rect">
+            <a:avLst/>
+          </a:prstGeom>
+          <a:solidFill>
+            <a:srgbClr val="FDB515"/>
+          </a:solidFill>
+          <a:ln>
+            <a:noFill/>
+          </a:ln>
+          <a:effectLst/>
+        </p:spPr>
+        <p:style>
+          <a:lnRef idx="1">
+            <a:schemeClr val="accent1"/>
+          </a:lnRef>
+          <a:fillRef idx="3">
+            <a:schemeClr val="accent1"/>
+          </a:fillRef>
+          <a:effectRef idx="2">
+            <a:schemeClr val="accent1"/>
+          </a:effectRef>
+          <a:fontRef idx="minor">
+            <a:schemeClr val="lt1"/>
+          </a:fontRef>
+        </p:style>
+        <p:txBody>
+          <a:bodyPr rtlCol="0" anchor="ctr"/>
+          <a:lstStyle/>
+          <a:p>
+            <a:pPr algn="ctr"/>
+          </a:p>
+        </p:txBody>
+      </p:sp>
+      <p:sp>
+        <p:nvSpPr>
+          <p:cNvPr id="14" name="TextBox 13"/>
+          <p:cNvSpPr txBox="1"/>
+          <p:nvPr/>
+        </p:nvSpPr>
+        <p:spPr>
+          <a:xfrm>
+            <a:off x="1097280" y="3616452"/>
+            <a:ext cx="4617720" cy="603503"/>
+          </a:xfrm>
+          <a:prstGeom prst="rect">
+            <a:avLst/>
+          </a:prstGeom>
+          <a:noFill/>
+        </p:spPr>
+        <p:txBody>
+          <a:bodyPr wrap="square" anchor="ctr" lIns="0" rIns="0" tIns="0" bIns="0">
+            <a:spAutoFit/>
+          </a:bodyPr>
+          <a:lstStyle/>
+          <a:p>
+            <a:pPr>
+              <a:spcAft>
+                <a:spcPts val="600"/>
+              </a:spcAft>
+            </a:pPr>
+            <a:r>
+              <a:rPr sz="1200" b="1" i="0">
+                <a:solidFill>
+                  <a:srgbClr val="FDB515"/>
+                </a:solidFill>
+                <a:latin typeface="Arial"/>
+              </a:rPr>
+              <a:t>CODE HYGIENE</a:t>
+            </a:r>
+          </a:p>
+          <a:p>
+            <a:pPr>
+              <a:lnSpc>
+                <a:spcPct val="110000"/>
+              </a:lnSpc>
+            </a:pPr>
+            <a:r>
+              <a:rPr sz="1450" b="0" i="1">
+                <a:solidFill>
+                  <a:srgbClr val="FFFFFF"/>
+                </a:solidFill>
+                <a:latin typeface="Arial"/>
+              </a:rPr>
+              <a:t>“uv run check --full and fix” — the 2nd most frequent command (50×).</a:t>
+            </a:r>
+          </a:p>
+        </p:txBody>
+      </p:sp>
+      <p:sp>
+        <p:nvSpPr>
+          <p:cNvPr id="15" name="Rectangle 14"/>
+          <p:cNvSpPr/>
+          <p:nvPr/>
+        </p:nvSpPr>
+        <p:spPr>
+          <a:xfrm>
+            <a:off x="6172200" y="3415284"/>
+            <a:ext cx="5166360" cy="914400"/>
+          </a:xfrm>
+          <a:prstGeom prst="rect">
+            <a:avLst/>
+          </a:prstGeom>
+          <a:solidFill>
+            <a:srgbClr val="003262"/>
+          </a:solidFill>
+          <a:ln>
+            <a:noFill/>
+          </a:ln>
+          <a:effectLst/>
+        </p:spPr>
+        <p:style>
+          <a:lnRef idx="1">
+            <a:schemeClr val="accent1"/>
+          </a:lnRef>
+          <a:fillRef idx="3">
+            <a:schemeClr val="accent1"/>
+          </a:fillRef>
+          <a:effectRef idx="2">
+            <a:schemeClr val="accent1"/>
+          </a:effectRef>
+          <a:fontRef idx="minor">
+            <a:schemeClr val="lt1"/>
+          </a:fontRef>
+        </p:style>
+        <p:txBody>
+          <a:bodyPr rtlCol="0" anchor="ctr"/>
+          <a:lstStyle/>
+          <a:p>
+            <a:pPr algn="ctr"/>
+          </a:p>
+        </p:txBody>
+      </p:sp>
+      <p:sp>
+        <p:nvSpPr>
+          <p:cNvPr id="16" name="Rectangle 15"/>
+          <p:cNvSpPr/>
+          <p:nvPr/>
+        </p:nvSpPr>
+        <p:spPr>
+          <a:xfrm>
+            <a:off x="6172200" y="3415284"/>
+            <a:ext cx="5166360" cy="91440"/>
+          </a:xfrm>
+          <a:prstGeom prst="rect">
+            <a:avLst/>
+          </a:prstGeom>
+          <a:solidFill>
+            <a:srgbClr val="FDB515"/>
+          </a:solidFill>
+          <a:ln>
+            <a:noFill/>
+          </a:ln>
+          <a:effectLst/>
+        </p:spPr>
+        <p:style>
+          <a:lnRef idx="1">
+            <a:schemeClr val="accent1"/>
+          </a:lnRef>
+          <a:fillRef idx="3">
+            <a:schemeClr val="accent1"/>
+          </a:fillRef>
+          <a:effectRef idx="2">
+            <a:schemeClr val="accent1"/>
+          </a:effectRef>
+          <a:fontRef idx="minor">
+            <a:schemeClr val="lt1"/>
+          </a:fontRef>
+        </p:style>
+        <p:txBody>
+          <a:bodyPr rtlCol="0" anchor="ctr"/>
+          <a:lstStyle/>
+          <a:p>
+            <a:pPr algn="ctr"/>
+          </a:p>
+        </p:txBody>
+      </p:sp>
+      <p:sp>
+        <p:nvSpPr>
+          <p:cNvPr id="17" name="TextBox 16"/>
+          <p:cNvSpPr txBox="1"/>
+          <p:nvPr/>
+        </p:nvSpPr>
+        <p:spPr>
+          <a:xfrm>
+            <a:off x="6446520" y="3616452"/>
+            <a:ext cx="4617720" cy="603503"/>
+          </a:xfrm>
+          <a:prstGeom prst="rect">
+            <a:avLst/>
+          </a:prstGeom>
+          <a:noFill/>
+        </p:spPr>
+        <p:txBody>
+          <a:bodyPr wrap="square" anchor="ctr" lIns="0" rIns="0" tIns="0" bIns="0">
+            <a:spAutoFit/>
+          </a:bodyPr>
+          <a:lstStyle/>
+          <a:p>
+            <a:pPr>
+              <a:spcAft>
+                <a:spcPts val="600"/>
+              </a:spcAft>
+            </a:pPr>
+            <a:r>
+              <a:rPr sz="1200" b="1" i="0">
+                <a:solidFill>
+                  <a:srgbClr val="FDB515"/>
+                </a:solidFill>
+                <a:latin typeface="Arial"/>
+              </a:rPr>
+              <a:t>DIRECTORY AUDIT</a:t>
+            </a:r>
+          </a:p>
+          <a:p>
+            <a:pPr>
+              <a:lnSpc>
+                <a:spcPct val="110000"/>
+              </a:lnSpc>
+            </a:pPr>
+            <a:r>
+              <a:rPr sz="1450" b="0" i="1">
+                <a:solidFill>
+                  <a:srgbClr val="FFFFFF"/>
+                </a:solidFill>
+                <a:latin typeface="Arial"/>
+              </a:rPr>
+              <a:t>“Find all bugs, redundancies, and inconsistencies in agents/vscode/.”</a:t>
+            </a:r>
+          </a:p>
+        </p:txBody>
+      </p:sp>
+      <p:sp>
+        <p:nvSpPr>
+          <p:cNvPr id="18" name="Rectangle 17"/>
+          <p:cNvSpPr/>
+          <p:nvPr/>
+        </p:nvSpPr>
+        <p:spPr>
+          <a:xfrm>
+            <a:off x="822960" y="4453128"/>
+            <a:ext cx="5166360" cy="914400"/>
+          </a:xfrm>
+          <a:prstGeom prst="rect">
+            <a:avLst/>
+          </a:prstGeom>
+          <a:solidFill>
+            <a:srgbClr val="003262"/>
+          </a:solidFill>
+          <a:ln>
+            <a:noFill/>
+          </a:ln>
+          <a:effectLst/>
+        </p:spPr>
+        <p:style>
+          <a:lnRef idx="1">
+            <a:schemeClr val="accent1"/>
+          </a:lnRef>
+          <a:fillRef idx="3">
+            <a:schemeClr val="accent1"/>
+          </a:fillRef>
+          <a:effectRef idx="2">
+            <a:schemeClr val="accent1"/>
+          </a:effectRef>
+          <a:fontRef idx="minor">
+            <a:schemeClr val="lt1"/>
+          </a:fontRef>
+        </p:style>
+        <p:txBody>
+          <a:bodyPr rtlCol="0" anchor="ctr"/>
+          <a:lstStyle/>
+          <a:p>
+            <a:pPr algn="ctr"/>
+          </a:p>
+        </p:txBody>
+      </p:sp>
+      <p:sp>
+        <p:nvSpPr>
+          <p:cNvPr id="19" name="Rectangle 18"/>
+          <p:cNvSpPr/>
+          <p:nvPr/>
+        </p:nvSpPr>
+        <p:spPr>
+          <a:xfrm>
+            <a:off x="822960" y="4453128"/>
+            <a:ext cx="5166360" cy="91440"/>
+          </a:xfrm>
+          <a:prstGeom prst="rect">
+            <a:avLst/>
+          </a:prstGeom>
+          <a:solidFill>
+            <a:srgbClr val="FDB515"/>
+          </a:solidFill>
+          <a:ln>
+            <a:noFill/>
+          </a:ln>
+          <a:effectLst/>
+        </p:spPr>
+        <p:style>
+          <a:lnRef idx="1">
+            <a:schemeClr val="accent1"/>
+          </a:lnRef>
+          <a:fillRef idx="3">
+            <a:schemeClr val="accent1"/>
+          </a:fillRef>
+          <a:effectRef idx="2">
+            <a:schemeClr val="accent1"/>
+          </a:effectRef>
+          <a:fontRef idx="minor">
+            <a:schemeClr val="lt1"/>
+          </a:fontRef>
+        </p:style>
+        <p:txBody>
+          <a:bodyPr rtlCol="0" anchor="ctr"/>
+          <a:lstStyle/>
+          <a:p>
+            <a:pPr algn="ctr"/>
+          </a:p>
+        </p:txBody>
+      </p:sp>
+      <p:sp>
+        <p:nvSpPr>
+          <p:cNvPr id="20" name="TextBox 19"/>
+          <p:cNvSpPr txBox="1"/>
+          <p:nvPr/>
+        </p:nvSpPr>
+        <p:spPr>
+          <a:xfrm>
+            <a:off x="1097280" y="4654296"/>
+            <a:ext cx="4617720" cy="603503"/>
+          </a:xfrm>
+          <a:prstGeom prst="rect">
+            <a:avLst/>
+          </a:prstGeom>
+          <a:noFill/>
+        </p:spPr>
+        <p:txBody>
+          <a:bodyPr wrap="square" anchor="ctr" lIns="0" rIns="0" tIns="0" bIns="0">
+            <a:spAutoFit/>
+          </a:bodyPr>
+          <a:lstStyle/>
+          <a:p>
+            <a:pPr>
+              <a:spcAft>
+                <a:spcPts val="600"/>
+              </a:spcAft>
+            </a:pPr>
+            <a:r>
+              <a:rPr sz="1200" b="1" i="0">
+                <a:solidFill>
+                  <a:srgbClr val="FDB515"/>
+                </a:solidFill>
+                <a:latin typeface="Arial"/>
+              </a:rPr>
+              <a:t>DEFENSIVE REVERT</a:t>
+            </a:r>
+          </a:p>
+          <a:p>
+            <a:pPr>
+              <a:lnSpc>
+                <a:spcPct val="110000"/>
+              </a:lnSpc>
+            </a:pPr>
+            <a:r>
+              <a:rPr sz="1450" b="0" i="1">
+                <a:solidFill>
+                  <a:srgbClr val="FFFFFF"/>
+                </a:solidFill>
+                <a:latin typeface="Arial"/>
+              </a:rPr>
+              <a:t>“Can you get rid of the last commit to main?” — recurs 30+ times.</a:t>
+            </a:r>
+          </a:p>
+        </p:txBody>
+      </p:sp>
+      <p:sp>
+        <p:nvSpPr>
+          <p:cNvPr id="21" name="Rectangle 20"/>
+          <p:cNvSpPr/>
+          <p:nvPr/>
+        </p:nvSpPr>
+        <p:spPr>
+          <a:xfrm>
+            <a:off x="6172200" y="4453128"/>
+            <a:ext cx="5166360" cy="914400"/>
+          </a:xfrm>
+          <a:prstGeom prst="rect">
+            <a:avLst/>
+          </a:prstGeom>
+          <a:solidFill>
+            <a:srgbClr val="003262"/>
+          </a:solidFill>
+          <a:ln>
+            <a:noFill/>
+          </a:ln>
+          <a:effectLst/>
+        </p:spPr>
+        <p:style>
+          <a:lnRef idx="1">
+            <a:schemeClr val="accent1"/>
+          </a:lnRef>
+          <a:fillRef idx="3">
+            <a:schemeClr val="accent1"/>
+          </a:fillRef>
+          <a:effectRef idx="2">
+            <a:schemeClr val="accent1"/>
+          </a:effectRef>
+          <a:fontRef idx="minor">
+            <a:schemeClr val="lt1"/>
+          </a:fontRef>
+        </p:style>
+        <p:txBody>
+          <a:bodyPr rtlCol="0" anchor="ctr"/>
+          <a:lstStyle/>
+          <a:p>
+            <a:pPr algn="ctr"/>
+          </a:p>
+        </p:txBody>
+      </p:sp>
+      <p:sp>
+        <p:nvSpPr>
+          <p:cNvPr id="22" name="Rectangle 21"/>
+          <p:cNvSpPr/>
+          <p:nvPr/>
+        </p:nvSpPr>
+        <p:spPr>
+          <a:xfrm>
+            <a:off x="6172200" y="4453128"/>
+            <a:ext cx="5166360" cy="91440"/>
+          </a:xfrm>
+          <a:prstGeom prst="rect">
+            <a:avLst/>
+          </a:prstGeom>
+          <a:solidFill>
+            <a:srgbClr val="FDB515"/>
+          </a:solidFill>
+          <a:ln>
+            <a:noFill/>
+          </a:ln>
+          <a:effectLst/>
+        </p:spPr>
+        <p:style>
+          <a:lnRef idx="1">
+            <a:schemeClr val="accent1"/>
+          </a:lnRef>
+          <a:fillRef idx="3">
+            <a:schemeClr val="accent1"/>
+          </a:fillRef>
+          <a:effectRef idx="2">
+            <a:schemeClr val="accent1"/>
+          </a:effectRef>
+          <a:fontRef idx="minor">
+            <a:schemeClr val="lt1"/>
+          </a:fontRef>
+        </p:style>
+        <p:txBody>
+          <a:bodyPr rtlCol="0" anchor="ctr"/>
+          <a:lstStyle/>
+          <a:p>
+            <a:pPr algn="ctr"/>
+          </a:p>
+        </p:txBody>
+      </p:sp>
+      <p:sp>
+        <p:nvSpPr>
+          <p:cNvPr id="23" name="TextBox 22"/>
+          <p:cNvSpPr txBox="1"/>
+          <p:nvPr/>
+        </p:nvSpPr>
+        <p:spPr>
+          <a:xfrm>
+            <a:off x="6446520" y="4654296"/>
+            <a:ext cx="4617720" cy="603503"/>
+          </a:xfrm>
+          <a:prstGeom prst="rect">
+            <a:avLst/>
+          </a:prstGeom>
+          <a:noFill/>
+        </p:spPr>
+        <p:txBody>
+          <a:bodyPr wrap="square" anchor="ctr" lIns="0" rIns="0" tIns="0" bIns="0">
+            <a:spAutoFit/>
+          </a:bodyPr>
+          <a:lstStyle/>
+          <a:p>
+            <a:pPr>
+              <a:spcAft>
+                <a:spcPts val="600"/>
+              </a:spcAft>
+            </a:pPr>
+            <a:r>
+              <a:rPr sz="1200" b="1" i="0">
+                <a:solidFill>
+                  <a:srgbClr val="FDB515"/>
+                </a:solidFill>
+                <a:latin typeface="Arial"/>
+              </a:rPr>
+              <a:t>ITERATIVE FEATURE</a:t>
+            </a:r>
+          </a:p>
+          <a:p>
+            <a:pPr>
+              <a:lnSpc>
+                <a:spcPct val="110000"/>
+              </a:lnSpc>
+            </a:pPr>
+            <a:r>
+              <a:rPr sz="1450" b="0" i="1">
+                <a:solidFill>
+                  <a:srgbClr val="FFFFFF"/>
+                </a:solidFill>
+                <a:latin typeface="Arial"/>
+              </a:rPr>
+              <a:t>“Let the user access KISS Sorcar from any device with a browser.”</a:t>
+            </a:r>
+          </a:p>
+        </p:txBody>
+      </p:sp>
+      <p:sp>
+        <p:nvSpPr>
+          <p:cNvPr id="24" name="Rectangle 23"/>
+          <p:cNvSpPr/>
+          <p:nvPr/>
+        </p:nvSpPr>
+        <p:spPr>
+          <a:xfrm>
+            <a:off x="822960" y="5490972"/>
+            <a:ext cx="5166360" cy="914400"/>
+          </a:xfrm>
+          <a:prstGeom prst="rect">
+            <a:avLst/>
+          </a:prstGeom>
+          <a:solidFill>
+            <a:srgbClr val="003262"/>
+          </a:solidFill>
+          <a:ln>
+            <a:noFill/>
+          </a:ln>
+          <a:effectLst/>
+        </p:spPr>
+        <p:style>
+          <a:lnRef idx="1">
+            <a:schemeClr val="accent1"/>
+          </a:lnRef>
+          <a:fillRef idx="3">
+            <a:schemeClr val="accent1"/>
+          </a:fillRef>
+          <a:effectRef idx="2">
+            <a:schemeClr val="accent1"/>
+          </a:effectRef>
+          <a:fontRef idx="minor">
+            <a:schemeClr val="lt1"/>
+          </a:fontRef>
+        </p:style>
+        <p:txBody>
+          <a:bodyPr rtlCol="0" anchor="ctr"/>
+          <a:lstStyle/>
+          <a:p>
+            <a:pPr algn="ctr"/>
+          </a:p>
+        </p:txBody>
+      </p:sp>
+      <p:sp>
+        <p:nvSpPr>
+          <p:cNvPr id="25" name="Rectangle 24"/>
+          <p:cNvSpPr/>
+          <p:nvPr/>
+        </p:nvSpPr>
+        <p:spPr>
+          <a:xfrm>
+            <a:off x="822960" y="5490972"/>
+            <a:ext cx="5166360" cy="91440"/>
+          </a:xfrm>
+          <a:prstGeom prst="rect">
+            <a:avLst/>
+          </a:prstGeom>
+          <a:solidFill>
+            <a:srgbClr val="FDB515"/>
+          </a:solidFill>
+          <a:ln>
+            <a:noFill/>
+          </a:ln>
+          <a:effectLst/>
+        </p:spPr>
+        <p:style>
+          <a:lnRef idx="1">
+            <a:schemeClr val="accent1"/>
+          </a:lnRef>
+          <a:fillRef idx="3">
+            <a:schemeClr val="accent1"/>
+          </a:fillRef>
+          <a:effectRef idx="2">
+            <a:schemeClr val="accent1"/>
+          </a:effectRef>
+          <a:fontRef idx="minor">
+            <a:schemeClr val="lt1"/>
+          </a:fontRef>
+        </p:style>
+        <p:txBody>
+          <a:bodyPr rtlCol="0" anchor="ctr"/>
+          <a:lstStyle/>
+          <a:p>
+            <a:pPr algn="ctr"/>
+          </a:p>
+        </p:txBody>
+      </p:sp>
+      <p:sp>
+        <p:nvSpPr>
+          <p:cNvPr id="26" name="TextBox 25"/>
+          <p:cNvSpPr txBox="1"/>
+          <p:nvPr/>
+        </p:nvSpPr>
+        <p:spPr>
+          <a:xfrm>
+            <a:off x="1097280" y="5692140"/>
+            <a:ext cx="4617720" cy="603503"/>
+          </a:xfrm>
+          <a:prstGeom prst="rect">
+            <a:avLst/>
+          </a:prstGeom>
+          <a:noFill/>
+        </p:spPr>
+        <p:txBody>
+          <a:bodyPr wrap="square" anchor="ctr" lIns="0" rIns="0" tIns="0" bIns="0">
+            <a:spAutoFit/>
+          </a:bodyPr>
+          <a:lstStyle/>
+          <a:p>
+            <a:pPr>
+              <a:spcAft>
+                <a:spcPts val="600"/>
+              </a:spcAft>
+            </a:pPr>
+            <a:r>
+              <a:rPr sz="1200" b="1" i="0">
+                <a:solidFill>
+                  <a:srgbClr val="FDB515"/>
+                </a:solidFill>
+                <a:latin typeface="Arial"/>
+              </a:rPr>
+              <a:t>INVESTIGATE FIRST</a:t>
+            </a:r>
+          </a:p>
+          <a:p>
+            <a:pPr>
+              <a:lnSpc>
+                <a:spcPct val="110000"/>
+              </a:lnSpc>
+            </a:pPr>
+            <a:r>
+              <a:rPr sz="1450" b="0" i="1">
+                <a:solidFill>
+                  <a:srgbClr val="FFFFFF"/>
+                </a:solidFill>
+                <a:latin typeface="Arial"/>
+              </a:rPr>
+              <a:t>“Show me the detailed step-by-step workflow of web_server.py.”</a:t>
+            </a:r>
+          </a:p>
+        </p:txBody>
+      </p:sp>
+      <p:sp>
+        <p:nvSpPr>
+          <p:cNvPr id="27" name="Rectangle 26"/>
+          <p:cNvSpPr/>
+          <p:nvPr/>
+        </p:nvSpPr>
+        <p:spPr>
+          <a:xfrm>
+            <a:off x="6172200" y="5490972"/>
+            <a:ext cx="5166360" cy="914400"/>
+          </a:xfrm>
+          <a:prstGeom prst="rect">
+            <a:avLst/>
+          </a:prstGeom>
+          <a:solidFill>
+            <a:srgbClr val="003262"/>
+          </a:solidFill>
+          <a:ln>
+            <a:noFill/>
+          </a:ln>
+          <a:effectLst/>
+        </p:spPr>
+        <p:style>
+          <a:lnRef idx="1">
+            <a:schemeClr val="accent1"/>
+          </a:lnRef>
+          <a:fillRef idx="3">
+            <a:schemeClr val="accent1"/>
+          </a:fillRef>
+          <a:effectRef idx="2">
+            <a:schemeClr val="accent1"/>
+          </a:effectRef>
+          <a:fontRef idx="minor">
+            <a:schemeClr val="lt1"/>
+          </a:fontRef>
+        </p:style>
+        <p:txBody>
+          <a:bodyPr rtlCol="0" anchor="ctr"/>
+          <a:lstStyle/>
+          <a:p>
+            <a:pPr algn="ctr"/>
+          </a:p>
+        </p:txBody>
+      </p:sp>
+      <p:sp>
+        <p:nvSpPr>
+          <p:cNvPr id="28" name="Rectangle 27"/>
+          <p:cNvSpPr/>
+          <p:nvPr/>
+        </p:nvSpPr>
+        <p:spPr>
+          <a:xfrm>
+            <a:off x="6172200" y="5490972"/>
+            <a:ext cx="5166360" cy="91440"/>
+          </a:xfrm>
+          <a:prstGeom prst="rect">
+            <a:avLst/>
+          </a:prstGeom>
+          <a:solidFill>
+            <a:srgbClr val="FDB515"/>
+          </a:solidFill>
+          <a:ln>
+            <a:noFill/>
+          </a:ln>
+          <a:effectLst/>
+        </p:spPr>
+        <p:style>
+          <a:lnRef idx="1">
+            <a:schemeClr val="accent1"/>
+          </a:lnRef>
+          <a:fillRef idx="3">
+            <a:schemeClr val="accent1"/>
+          </a:fillRef>
+          <a:effectRef idx="2">
+            <a:schemeClr val="accent1"/>
+          </a:effectRef>
+          <a:fontRef idx="minor">
+            <a:schemeClr val="lt1"/>
+          </a:fontRef>
+        </p:style>
+        <p:txBody>
+          <a:bodyPr rtlCol="0" anchor="ctr"/>
+          <a:lstStyle/>
+          <a:p>
+            <a:pPr algn="ctr"/>
+          </a:p>
+        </p:txBody>
+      </p:sp>
+      <p:sp>
+        <p:nvSpPr>
+          <p:cNvPr id="29" name="TextBox 28"/>
+          <p:cNvSpPr txBox="1"/>
+          <p:nvPr/>
+        </p:nvSpPr>
+        <p:spPr>
+          <a:xfrm>
+            <a:off x="6446520" y="5692140"/>
+            <a:ext cx="4617720" cy="603503"/>
+          </a:xfrm>
+          <a:prstGeom prst="rect">
+            <a:avLst/>
+          </a:prstGeom>
+          <a:noFill/>
+        </p:spPr>
+        <p:txBody>
+          <a:bodyPr wrap="square" anchor="ctr" lIns="0" rIns="0" tIns="0" bIns="0">
+            <a:spAutoFit/>
+          </a:bodyPr>
+          <a:lstStyle/>
+          <a:p>
+            <a:pPr>
+              <a:spcAft>
+                <a:spcPts val="600"/>
+              </a:spcAft>
+            </a:pPr>
+            <a:r>
+              <a:rPr sz="1200" b="1" i="0">
+                <a:solidFill>
+                  <a:srgbClr val="FDB515"/>
+                </a:solidFill>
+                <a:latin typeface="Arial"/>
+              </a:rPr>
+              <a:t>PROMPT ENGINEERING</a:t>
+            </a:r>
+          </a:p>
+          <a:p>
+            <a:pPr>
+              <a:lnSpc>
+                <a:spcPct val="110000"/>
+              </a:lnSpc>
+            </a:pPr>
+            <a:r>
+              <a:rPr sz="1450" b="0" i="1">
+                <a:solidFill>
+                  <a:srgbClr val="FFFFFF"/>
+                </a:solidFill>
+                <a:latin typeface="Arial"/>
+              </a:rPr>
+              <a:t>“Which SYSTEM.md instructions were not followed yesterday? Fix them.”</a:t>
+            </a:r>
+          </a:p>
+        </p:txBody>
+      </p:sp>
+      <p:sp>
+        <p:nvSpPr>
+          <p:cNvPr id="30" name="Rectangle 29"/>
+          <p:cNvSpPr/>
+          <p:nvPr/>
+        </p:nvSpPr>
+        <p:spPr>
+          <a:xfrm>
+            <a:off x="0" y="6510528"/>
+            <a:ext cx="12188952" cy="27432"/>
+          </a:xfrm>
+          <a:prstGeom prst="rect">
+            <a:avLst/>
+          </a:prstGeom>
+          <a:solidFill>
+            <a:srgbClr val="E9E5D8"/>
+          </a:solidFill>
+          <a:ln>
+            <a:noFill/>
+          </a:ln>
+          <a:effectLst/>
+        </p:spPr>
+        <p:style>
+          <a:lnRef idx="1">
+            <a:schemeClr val="accent1"/>
+          </a:lnRef>
+          <a:fillRef idx="3">
+            <a:schemeClr val="accent1"/>
+          </a:fillRef>
+          <a:effectRef idx="2">
+            <a:schemeClr val="accent1"/>
+          </a:effectRef>
+          <a:fontRef idx="minor">
+            <a:schemeClr val="lt1"/>
+          </a:fontRef>
+        </p:style>
+        <p:txBody>
+          <a:bodyPr rtlCol="0" anchor="ctr"/>
+          <a:lstStyle/>
+          <a:p>
+            <a:pPr algn="ctr"/>
+          </a:p>
+        </p:txBody>
+      </p:sp>
+      <p:sp>
+        <p:nvSpPr>
+          <p:cNvPr id="31" name="TextBox 30"/>
+          <p:cNvSpPr txBox="1"/>
+          <p:nvPr/>
+        </p:nvSpPr>
+        <p:spPr>
+          <a:xfrm>
+            <a:off x="822960" y="6547104"/>
+            <a:ext cx="8229600" cy="274320"/>
+          </a:xfrm>
+          <a:prstGeom prst="rect">
+            <a:avLst/>
+          </a:prstGeom>
+          <a:noFill/>
+        </p:spPr>
+        <p:txBody>
+          <a:bodyPr wrap="square" anchor="t" lIns="0" rIns="0" tIns="0" bIns="0">
+            <a:spAutoFit/>
+          </a:bodyPr>
+          <a:lstStyle/>
+          <a:p>
+            <a:r>
+              <a:rPr sz="1100" b="0" i="0">
+                <a:solidFill>
+                  <a:srgbClr val="4A5260"/>
+                </a:solidFill>
+                <a:latin typeface="Arial"/>
+              </a:rPr>
+              <a:t>KISS Sorcar  ·  K. Sen, UC Berkeley</a:t>
+            </a:r>
+          </a:p>
+        </p:txBody>
+      </p:sp>
+      <p:sp>
+        <p:nvSpPr>
+          <p:cNvPr id="32" name="TextBox 31"/>
+          <p:cNvSpPr txBox="1"/>
+          <p:nvPr/>
+        </p:nvSpPr>
+        <p:spPr>
+          <a:xfrm>
+            <a:off x="10058400" y="6547104"/>
+            <a:ext cx="1307592" cy="274320"/>
+          </a:xfrm>
+          <a:prstGeom prst="rect">
+            <a:avLst/>
+          </a:prstGeom>
+          <a:noFill/>
+        </p:spPr>
+        <p:txBody>
+          <a:bodyPr wrap="square" anchor="t" lIns="0" rIns="0" tIns="0" bIns="0">
+            <a:spAutoFit/>
+          </a:bodyPr>
+          <a:lstStyle/>
+          <a:p>
+            <a:pPr algn="r"/>
+            <a:r>
+              <a:rPr sz="1100" b="1" i="0">
+                <a:solidFill>
+                  <a:srgbClr val="C88A00"/>
+                </a:solidFill>
+                <a:latin typeface="Arial"/>
+              </a:rPr>
+              <a:t>15</a:t>
+            </a:r>
+          </a:p>
+        </p:txBody>
+      </p:sp>
+    </p:spTree>
+  </p:cSld>
+  <p:clrMapOvr>
+    <a:masterClrMapping/>
+  </p:clrMapOvr>
+</p:sld>
+</file>
+
+<file path=ppt/slides/slide24.xml><?xml version="1.0" encoding="utf-8"?>
+<p:sld xmlns:a="http://schemas.openxmlformats.org/drawingml/2006/main" xmlns:p="http://schemas.openxmlformats.org/presentationml/2006/main" xmlns:r="http://schemas.openxmlformats.org/officeDocument/2006/relationships">
+  <p:cSld>
+    <p:bg>
+      <p:bgPr>
+        <a:solidFill>
+          <a:srgbClr val="F7F5EF"/>
+        </a:solidFill>
+        <a:effectLst/>
+      </p:bgPr>
+    </p:bg>
+    <p:spTree>
+      <p:nvGrpSpPr>
+        <p:cNvPr id="1" name=""/>
+        <p:cNvGrpSpPr/>
+        <p:nvPr/>
+      </p:nvGrpSpPr>
+      <p:grpSpPr/>
+      <p:sp>
+        <p:nvSpPr>
+          <p:cNvPr id="2" name="Rectangle 1"/>
+          <p:cNvSpPr/>
+          <p:nvPr/>
+        </p:nvSpPr>
+        <p:spPr>
+          <a:xfrm>
+            <a:off x="457200" y="914400"/>
+            <a:ext cx="146304" cy="502920"/>
+          </a:xfrm>
+          <a:prstGeom prst="rect">
+            <a:avLst/>
+          </a:prstGeom>
+          <a:solidFill>
+            <a:srgbClr val="FDB515"/>
+          </a:solidFill>
+          <a:ln>
+            <a:noFill/>
+          </a:ln>
+          <a:effectLst/>
+        </p:spPr>
+        <p:style>
+          <a:lnRef idx="1">
+            <a:schemeClr val="accent1"/>
+          </a:lnRef>
+          <a:fillRef idx="3">
+            <a:schemeClr val="accent1"/>
+          </a:fillRef>
+          <a:effectRef idx="2">
+            <a:schemeClr val="accent1"/>
+          </a:effectRef>
+          <a:fontRef idx="minor">
+            <a:schemeClr val="lt1"/>
+          </a:fontRef>
+        </p:style>
+        <p:txBody>
+          <a:bodyPr rtlCol="0" anchor="ctr"/>
+          <a:lstStyle/>
+          <a:p>
+            <a:pPr algn="ctr"/>
+          </a:p>
+        </p:txBody>
+      </p:sp>
+      <p:sp>
+        <p:nvSpPr>
+          <p:cNvPr id="3" name="TextBox 2"/>
+          <p:cNvSpPr txBox="1"/>
+          <p:nvPr/>
+        </p:nvSpPr>
+        <p:spPr>
+          <a:xfrm>
+            <a:off x="822960" y="502920"/>
+            <a:ext cx="10515600" cy="365760"/>
+          </a:xfrm>
+          <a:prstGeom prst="rect">
+            <a:avLst/>
+          </a:prstGeom>
+          <a:noFill/>
+        </p:spPr>
+        <p:txBody>
+          <a:bodyPr wrap="square" anchor="t" lIns="0" rIns="0" tIns="0" bIns="0">
+            <a:spAutoFit/>
+          </a:bodyPr>
+          <a:lstStyle/>
+          <a:p>
+            <a:r>
+              <a:rPr sz="1300" b="1" i="0">
+                <a:solidFill>
+                  <a:srgbClr val="C88A00"/>
+                </a:solidFill>
+                <a:latin typeface="Arial"/>
+              </a:rPr>
+              <a:t>F  R  O  M      T  H  E      L  O  G</a:t>
+            </a:r>
+          </a:p>
+        </p:txBody>
+      </p:sp>
+      <p:sp>
+        <p:nvSpPr>
+          <p:cNvPr id="4" name="TextBox 3"/>
+          <p:cNvSpPr txBox="1"/>
+          <p:nvPr/>
+        </p:nvSpPr>
+        <p:spPr>
+          <a:xfrm>
+            <a:off x="822960" y="868680"/>
+            <a:ext cx="10515600" cy="1280160"/>
+          </a:xfrm>
+          <a:prstGeom prst="rect">
+            <a:avLst/>
+          </a:prstGeom>
+          <a:noFill/>
+        </p:spPr>
+        <p:txBody>
+          <a:bodyPr wrap="square" anchor="t" lIns="0" rIns="0" tIns="0" bIns="0">
+            <a:spAutoFit/>
+          </a:bodyPr>
+          <a:lstStyle/>
+          <a:p>
+            <a:r>
+              <a:rPr sz="3400" b="1" i="0">
+                <a:solidFill>
+                  <a:srgbClr val="003262"/>
+                </a:solidFill>
+                <a:latin typeface="Arial"/>
+              </a:rPr>
+              <a:t>Verbatim user tasks — general assistance</a:t>
+            </a:r>
+          </a:p>
+        </p:txBody>
+      </p:sp>
+      <p:sp>
+        <p:nvSpPr>
+          <p:cNvPr id="5" name="TextBox 4"/>
+          <p:cNvSpPr txBox="1"/>
+          <p:nvPr/>
+        </p:nvSpPr>
+        <p:spPr>
+          <a:xfrm>
+            <a:off x="822960" y="1783080"/>
+            <a:ext cx="10607040" cy="502920"/>
+          </a:xfrm>
+          <a:prstGeom prst="rect">
+            <a:avLst/>
+          </a:prstGeom>
+          <a:noFill/>
+        </p:spPr>
+        <p:txBody>
+          <a:bodyPr wrap="square" anchor="t" lIns="0" rIns="0" tIns="0" bIns="0">
+            <a:spAutoFit/>
+          </a:bodyPr>
+          <a:lstStyle/>
+          <a:p>
+            <a:pPr>
+              <a:lnSpc>
+                <a:spcPct val="112000"/>
+              </a:lnSpc>
+            </a:pPr>
+            <a:r>
+              <a:rPr sz="2100" b="0" i="0">
+                <a:solidFill>
+                  <a:srgbClr val="4A5260"/>
+                </a:solidFill>
+                <a:latin typeface="Arial"/>
+              </a:rPr>
+              <a:t>The same agent, prompt, and architecture handle everything beyond code.</a:t>
+            </a:r>
+          </a:p>
+        </p:txBody>
+      </p:sp>
+      <p:sp>
+        <p:nvSpPr>
+          <p:cNvPr id="6" name="Rectangle 5"/>
+          <p:cNvSpPr/>
+          <p:nvPr/>
+        </p:nvSpPr>
+        <p:spPr>
+          <a:xfrm>
+            <a:off x="822960" y="2377440"/>
+            <a:ext cx="5166360" cy="914400"/>
+          </a:xfrm>
+          <a:prstGeom prst="rect">
+            <a:avLst/>
+          </a:prstGeom>
+          <a:solidFill>
+            <a:srgbClr val="003262"/>
+          </a:solidFill>
+          <a:ln>
+            <a:noFill/>
+          </a:ln>
+          <a:effectLst/>
+        </p:spPr>
+        <p:style>
+          <a:lnRef idx="1">
+            <a:schemeClr val="accent1"/>
+          </a:lnRef>
+          <a:fillRef idx="3">
+            <a:schemeClr val="accent1"/>
+          </a:fillRef>
+          <a:effectRef idx="2">
+            <a:schemeClr val="accent1"/>
+          </a:effectRef>
+          <a:fontRef idx="minor">
+            <a:schemeClr val="lt1"/>
+          </a:fontRef>
+        </p:style>
+        <p:txBody>
+          <a:bodyPr rtlCol="0" anchor="ctr"/>
+          <a:lstStyle/>
+          <a:p>
+            <a:pPr algn="ctr"/>
+          </a:p>
+        </p:txBody>
+      </p:sp>
+      <p:sp>
+        <p:nvSpPr>
+          <p:cNvPr id="7" name="Rectangle 6"/>
+          <p:cNvSpPr/>
+          <p:nvPr/>
+        </p:nvSpPr>
+        <p:spPr>
+          <a:xfrm>
+            <a:off x="822960" y="2377440"/>
+            <a:ext cx="5166360" cy="91440"/>
+          </a:xfrm>
+          <a:prstGeom prst="rect">
+            <a:avLst/>
+          </a:prstGeom>
+          <a:solidFill>
+            <a:srgbClr val="FDB515"/>
+          </a:solidFill>
+          <a:ln>
+            <a:noFill/>
+          </a:ln>
+          <a:effectLst/>
+        </p:spPr>
+        <p:style>
+          <a:lnRef idx="1">
+            <a:schemeClr val="accent1"/>
+          </a:lnRef>
+          <a:fillRef idx="3">
+            <a:schemeClr val="accent1"/>
+          </a:fillRef>
+          <a:effectRef idx="2">
+            <a:schemeClr val="accent1"/>
+          </a:effectRef>
+          <a:fontRef idx="minor">
+            <a:schemeClr val="lt1"/>
+          </a:fontRef>
+        </p:style>
+        <p:txBody>
+          <a:bodyPr rtlCol="0" anchor="ctr"/>
+          <a:lstStyle/>
+          <a:p>
+            <a:pPr algn="ctr"/>
+          </a:p>
+        </p:txBody>
+      </p:sp>
+      <p:sp>
+        <p:nvSpPr>
+          <p:cNvPr id="8" name="TextBox 7"/>
+          <p:cNvSpPr txBox="1"/>
+          <p:nvPr/>
+        </p:nvSpPr>
+        <p:spPr>
+          <a:xfrm>
+            <a:off x="1097280" y="2578608"/>
+            <a:ext cx="4617720" cy="603503"/>
+          </a:xfrm>
+          <a:prstGeom prst="rect">
+            <a:avLst/>
+          </a:prstGeom>
+          <a:noFill/>
+        </p:spPr>
+        <p:txBody>
+          <a:bodyPr wrap="square" anchor="ctr" lIns="0" rIns="0" tIns="0" bIns="0">
+            <a:spAutoFit/>
+          </a:bodyPr>
+          <a:lstStyle/>
+          <a:p>
+            <a:pPr>
+              <a:spcAft>
+                <a:spcPts val="600"/>
+              </a:spcAft>
+            </a:pPr>
+            <a:r>
+              <a:rPr sz="1200" b="1" i="0">
+                <a:solidFill>
+                  <a:srgbClr val="FDB515"/>
+                </a:solidFill>
+                <a:latin typeface="Arial"/>
+              </a:rPr>
+              <a:t>SMART HOME</a:t>
+            </a:r>
+          </a:p>
+          <a:p>
+            <a:pPr>
+              <a:lnSpc>
+                <a:spcPct val="110000"/>
+              </a:lnSpc>
+            </a:pPr>
+            <a:r>
+              <a:rPr sz="1450" b="0" i="1">
+                <a:solidFill>
+                  <a:srgbClr val="FFFFFF"/>
+                </a:solidFill>
+                <a:latin typeface="Arial"/>
+              </a:rPr>
+              <a:t>“Turn off the living room and family room lights.” (Govee API)</a:t>
+            </a:r>
+          </a:p>
+        </p:txBody>
+      </p:sp>
+      <p:sp>
+        <p:nvSpPr>
+          <p:cNvPr id="9" name="Rectangle 8"/>
+          <p:cNvSpPr/>
+          <p:nvPr/>
+        </p:nvSpPr>
+        <p:spPr>
+          <a:xfrm>
+            <a:off x="6172200" y="2377440"/>
+            <a:ext cx="5166360" cy="914400"/>
+          </a:xfrm>
+          <a:prstGeom prst="rect">
+            <a:avLst/>
+          </a:prstGeom>
+          <a:solidFill>
+            <a:srgbClr val="003262"/>
+          </a:solidFill>
+          <a:ln>
+            <a:noFill/>
+          </a:ln>
+          <a:effectLst/>
+        </p:spPr>
+        <p:style>
+          <a:lnRef idx="1">
+            <a:schemeClr val="accent1"/>
+          </a:lnRef>
+          <a:fillRef idx="3">
+            <a:schemeClr val="accent1"/>
+          </a:fillRef>
+          <a:effectRef idx="2">
+            <a:schemeClr val="accent1"/>
+          </a:effectRef>
+          <a:fontRef idx="minor">
+            <a:schemeClr val="lt1"/>
+          </a:fontRef>
+        </p:style>
+        <p:txBody>
+          <a:bodyPr rtlCol="0" anchor="ctr"/>
+          <a:lstStyle/>
+          <a:p>
+            <a:pPr algn="ctr"/>
+          </a:p>
+        </p:txBody>
+      </p:sp>
+      <p:sp>
+        <p:nvSpPr>
+          <p:cNvPr id="10" name="Rectangle 9"/>
+          <p:cNvSpPr/>
+          <p:nvPr/>
+        </p:nvSpPr>
+        <p:spPr>
+          <a:xfrm>
+            <a:off x="6172200" y="2377440"/>
+            <a:ext cx="5166360" cy="91440"/>
+          </a:xfrm>
+          <a:prstGeom prst="rect">
+            <a:avLst/>
+          </a:prstGeom>
+          <a:solidFill>
+            <a:srgbClr val="FDB515"/>
+          </a:solidFill>
+          <a:ln>
+            <a:noFill/>
+          </a:ln>
+          <a:effectLst/>
+        </p:spPr>
+        <p:style>
+          <a:lnRef idx="1">
+            <a:schemeClr val="accent1"/>
+          </a:lnRef>
+          <a:fillRef idx="3">
+            <a:schemeClr val="accent1"/>
+          </a:fillRef>
+          <a:effectRef idx="2">
+            <a:schemeClr val="accent1"/>
+          </a:effectRef>
+          <a:fontRef idx="minor">
+            <a:schemeClr val="lt1"/>
+          </a:fontRef>
+        </p:style>
+        <p:txBody>
+          <a:bodyPr rtlCol="0" anchor="ctr"/>
+          <a:lstStyle/>
+          <a:p>
+            <a:pPr algn="ctr"/>
+          </a:p>
+        </p:txBody>
+      </p:sp>
+      <p:sp>
+        <p:nvSpPr>
+          <p:cNvPr id="11" name="TextBox 10"/>
+          <p:cNvSpPr txBox="1"/>
+          <p:nvPr/>
+        </p:nvSpPr>
+        <p:spPr>
+          <a:xfrm>
+            <a:off x="6446520" y="2578608"/>
+            <a:ext cx="4617720" cy="603503"/>
+          </a:xfrm>
+          <a:prstGeom prst="rect">
+            <a:avLst/>
+          </a:prstGeom>
+          <a:noFill/>
+        </p:spPr>
+        <p:txBody>
+          <a:bodyPr wrap="square" anchor="ctr" lIns="0" rIns="0" tIns="0" bIns="0">
+            <a:spAutoFit/>
+          </a:bodyPr>
+          <a:lstStyle/>
+          <a:p>
+            <a:pPr>
+              <a:spcAft>
+                <a:spcPts val="600"/>
+              </a:spcAft>
+            </a:pPr>
+            <a:r>
+              <a:rPr sz="1200" b="1" i="0">
+                <a:solidFill>
+                  <a:srgbClr val="FDB515"/>
+                </a:solidFill>
+                <a:latin typeface="Arial"/>
+              </a:rPr>
+              <a:t>TRAVEL</a:t>
+            </a:r>
+          </a:p>
+          <a:p>
+            <a:pPr>
+              <a:lnSpc>
+                <a:spcPct val="110000"/>
+              </a:lnSpc>
+            </a:pPr>
+            <a:r>
+              <a:rPr sz="1450" b="0" i="1">
+                <a:solidFill>
+                  <a:srgbClr val="FFFFFF"/>
+                </a:solidFill>
+                <a:latin typeface="Arial"/>
+              </a:rPr>
+              <a:t>“Plan me a trip to Yosemite” — with hotel availability checks.</a:t>
+            </a:r>
+          </a:p>
+        </p:txBody>
+      </p:sp>
+      <p:sp>
+        <p:nvSpPr>
+          <p:cNvPr id="12" name="Rectangle 11"/>
+          <p:cNvSpPr/>
+          <p:nvPr/>
+        </p:nvSpPr>
+        <p:spPr>
+          <a:xfrm>
+            <a:off x="822960" y="3415284"/>
+            <a:ext cx="5166360" cy="914400"/>
+          </a:xfrm>
+          <a:prstGeom prst="rect">
+            <a:avLst/>
+          </a:prstGeom>
+          <a:solidFill>
+            <a:srgbClr val="003262"/>
+          </a:solidFill>
+          <a:ln>
+            <a:noFill/>
+          </a:ln>
+          <a:effectLst/>
+        </p:spPr>
+        <p:style>
+          <a:lnRef idx="1">
+            <a:schemeClr val="accent1"/>
+          </a:lnRef>
+          <a:fillRef idx="3">
+            <a:schemeClr val="accent1"/>
+          </a:fillRef>
+          <a:effectRef idx="2">
+            <a:schemeClr val="accent1"/>
+          </a:effectRef>
+          <a:fontRef idx="minor">
+            <a:schemeClr val="lt1"/>
+          </a:fontRef>
+        </p:style>
+        <p:txBody>
+          <a:bodyPr rtlCol="0" anchor="ctr"/>
+          <a:lstStyle/>
+          <a:p>
+            <a:pPr algn="ctr"/>
+          </a:p>
+        </p:txBody>
+      </p:sp>
+      <p:sp>
+        <p:nvSpPr>
+          <p:cNvPr id="13" name="Rectangle 12"/>
+          <p:cNvSpPr/>
+          <p:nvPr/>
+        </p:nvSpPr>
+        <p:spPr>
+          <a:xfrm>
+            <a:off x="822960" y="3415284"/>
+            <a:ext cx="5166360" cy="91440"/>
+          </a:xfrm>
+          <a:prstGeom prst="rect">
+            <a:avLst/>
+          </a:prstGeom>
+          <a:solidFill>
+            <a:srgbClr val="FDB515"/>
+          </a:solidFill>
+          <a:ln>
+            <a:noFill/>
+          </a:ln>
+          <a:effectLst/>
+        </p:spPr>
+        <p:style>
+          <a:lnRef idx="1">
+            <a:schemeClr val="accent1"/>
+          </a:lnRef>
+          <a:fillRef idx="3">
+            <a:schemeClr val="accent1"/>
+          </a:fillRef>
+          <a:effectRef idx="2">
+            <a:schemeClr val="accent1"/>
+          </a:effectRef>
+          <a:fontRef idx="minor">
+            <a:schemeClr val="lt1"/>
+          </a:fontRef>
+        </p:style>
+        <p:txBody>
+          <a:bodyPr rtlCol="0" anchor="ctr"/>
+          <a:lstStyle/>
+          <a:p>
+            <a:pPr algn="ctr"/>
+          </a:p>
+        </p:txBody>
+      </p:sp>
+      <p:sp>
+        <p:nvSpPr>
+          <p:cNvPr id="14" name="TextBox 13"/>
+          <p:cNvSpPr txBox="1"/>
+          <p:nvPr/>
+        </p:nvSpPr>
+        <p:spPr>
+          <a:xfrm>
+            <a:off x="1097280" y="3616452"/>
+            <a:ext cx="4617720" cy="603503"/>
+          </a:xfrm>
+          <a:prstGeom prst="rect">
+            <a:avLst/>
+          </a:prstGeom>
+          <a:noFill/>
+        </p:spPr>
+        <p:txBody>
+          <a:bodyPr wrap="square" anchor="ctr" lIns="0" rIns="0" tIns="0" bIns="0">
+            <a:spAutoFit/>
+          </a:bodyPr>
+          <a:lstStyle/>
+          <a:p>
+            <a:pPr>
+              <a:spcAft>
+                <a:spcPts val="600"/>
+              </a:spcAft>
+            </a:pPr>
+            <a:r>
+              <a:rPr sz="1200" b="1" i="0">
+                <a:solidFill>
+                  <a:srgbClr val="FDB515"/>
+                </a:solidFill>
+                <a:latin typeface="Arial"/>
+              </a:rPr>
+              <a:t>WEATHER</a:t>
+            </a:r>
+          </a:p>
+          <a:p>
+            <a:pPr>
+              <a:lnSpc>
+                <a:spcPct val="110000"/>
+              </a:lnSpc>
+            </a:pPr>
+            <a:r>
+              <a:rPr sz="1450" b="0" i="1">
+                <a:solidFill>
+                  <a:srgbClr val="FFFFFF"/>
+                </a:solidFill>
+                <a:latin typeface="Arial"/>
+              </a:rPr>
+              <a:t>“How is the weather today?” — answered from live sources, never stale data.</a:t>
+            </a:r>
+          </a:p>
+        </p:txBody>
+      </p:sp>
+      <p:sp>
+        <p:nvSpPr>
+          <p:cNvPr id="15" name="Rectangle 14"/>
+          <p:cNvSpPr/>
+          <p:nvPr/>
+        </p:nvSpPr>
+        <p:spPr>
+          <a:xfrm>
+            <a:off x="6172200" y="3415284"/>
+            <a:ext cx="5166360" cy="914400"/>
+          </a:xfrm>
+          <a:prstGeom prst="rect">
+            <a:avLst/>
+          </a:prstGeom>
+          <a:solidFill>
+            <a:srgbClr val="003262"/>
+          </a:solidFill>
+          <a:ln>
+            <a:noFill/>
+          </a:ln>
+          <a:effectLst/>
+        </p:spPr>
+        <p:style>
+          <a:lnRef idx="1">
+            <a:schemeClr val="accent1"/>
+          </a:lnRef>
+          <a:fillRef idx="3">
+            <a:schemeClr val="accent1"/>
+          </a:fillRef>
+          <a:effectRef idx="2">
+            <a:schemeClr val="accent1"/>
+          </a:effectRef>
+          <a:fontRef idx="minor">
+            <a:schemeClr val="lt1"/>
+          </a:fontRef>
+        </p:style>
+        <p:txBody>
+          <a:bodyPr rtlCol="0" anchor="ctr"/>
+          <a:lstStyle/>
+          <a:p>
+            <a:pPr algn="ctr"/>
+          </a:p>
+        </p:txBody>
+      </p:sp>
+      <p:sp>
+        <p:nvSpPr>
+          <p:cNvPr id="16" name="Rectangle 15"/>
+          <p:cNvSpPr/>
+          <p:nvPr/>
+        </p:nvSpPr>
+        <p:spPr>
+          <a:xfrm>
+            <a:off x="6172200" y="3415284"/>
+            <a:ext cx="5166360" cy="91440"/>
+          </a:xfrm>
+          <a:prstGeom prst="rect">
+            <a:avLst/>
+          </a:prstGeom>
+          <a:solidFill>
+            <a:srgbClr val="FDB515"/>
+          </a:solidFill>
+          <a:ln>
+            <a:noFill/>
+          </a:ln>
+          <a:effectLst/>
+        </p:spPr>
+        <p:style>
+          <a:lnRef idx="1">
+            <a:schemeClr val="accent1"/>
+          </a:lnRef>
+          <a:fillRef idx="3">
+            <a:schemeClr val="accent1"/>
+          </a:fillRef>
+          <a:effectRef idx="2">
+            <a:schemeClr val="accent1"/>
+          </a:effectRef>
+          <a:fontRef idx="minor">
+            <a:schemeClr val="lt1"/>
+          </a:fontRef>
+        </p:style>
+        <p:txBody>
+          <a:bodyPr rtlCol="0" anchor="ctr"/>
+          <a:lstStyle/>
+          <a:p>
+            <a:pPr algn="ctr"/>
+          </a:p>
+        </p:txBody>
+      </p:sp>
+      <p:sp>
+        <p:nvSpPr>
+          <p:cNvPr id="17" name="TextBox 16"/>
+          <p:cNvSpPr txBox="1"/>
+          <p:nvPr/>
+        </p:nvSpPr>
+        <p:spPr>
+          <a:xfrm>
+            <a:off x="6446520" y="3616452"/>
+            <a:ext cx="4617720" cy="603503"/>
+          </a:xfrm>
+          <a:prstGeom prst="rect">
+            <a:avLst/>
+          </a:prstGeom>
+          <a:noFill/>
+        </p:spPr>
+        <p:txBody>
+          <a:bodyPr wrap="square" anchor="ctr" lIns="0" rIns="0" tIns="0" bIns="0">
+            <a:spAutoFit/>
+          </a:bodyPr>
+          <a:lstStyle/>
+          <a:p>
+            <a:pPr>
+              <a:spcAft>
+                <a:spcPts val="600"/>
+              </a:spcAft>
+            </a:pPr>
+            <a:r>
+              <a:rPr sz="1200" b="1" i="0">
+                <a:solidFill>
+                  <a:srgbClr val="FDB515"/>
+                </a:solidFill>
+                <a:latin typeface="Arial"/>
+              </a:rPr>
+              <a:t>SHOPPING</a:t>
+            </a:r>
+          </a:p>
+          <a:p>
+            <a:pPr>
+              <a:lnSpc>
+                <a:spcPct val="110000"/>
+              </a:lnSpc>
+            </a:pPr>
+            <a:r>
+              <a:rPr sz="1450" b="0" i="1">
+                <a:solidFill>
+                  <a:srgbClr val="FFFFFF"/>
+                </a:solidFill>
+                <a:latin typeface="Arial"/>
+              </a:rPr>
+              <a:t>“Where can I find Darjeeling tea in the Bay Area?”</a:t>
+            </a:r>
+          </a:p>
+        </p:txBody>
+      </p:sp>
+      <p:sp>
+        <p:nvSpPr>
+          <p:cNvPr id="18" name="Rectangle 17"/>
+          <p:cNvSpPr/>
+          <p:nvPr/>
+        </p:nvSpPr>
+        <p:spPr>
+          <a:xfrm>
+            <a:off x="822960" y="4453128"/>
+            <a:ext cx="5166360" cy="914400"/>
+          </a:xfrm>
+          <a:prstGeom prst="rect">
+            <a:avLst/>
+          </a:prstGeom>
+          <a:solidFill>
+            <a:srgbClr val="003262"/>
+          </a:solidFill>
+          <a:ln>
+            <a:noFill/>
+          </a:ln>
+          <a:effectLst/>
+        </p:spPr>
+        <p:style>
+          <a:lnRef idx="1">
+            <a:schemeClr val="accent1"/>
+          </a:lnRef>
+          <a:fillRef idx="3">
+            <a:schemeClr val="accent1"/>
+          </a:fillRef>
+          <a:effectRef idx="2">
+            <a:schemeClr val="accent1"/>
+          </a:effectRef>
+          <a:fontRef idx="minor">
+            <a:schemeClr val="lt1"/>
+          </a:fontRef>
+        </p:style>
+        <p:txBody>
+          <a:bodyPr rtlCol="0" anchor="ctr"/>
+          <a:lstStyle/>
+          <a:p>
+            <a:pPr algn="ctr"/>
+          </a:p>
+        </p:txBody>
+      </p:sp>
+      <p:sp>
+        <p:nvSpPr>
+          <p:cNvPr id="19" name="Rectangle 18"/>
+          <p:cNvSpPr/>
+          <p:nvPr/>
+        </p:nvSpPr>
+        <p:spPr>
+          <a:xfrm>
+            <a:off x="822960" y="4453128"/>
+            <a:ext cx="5166360" cy="91440"/>
+          </a:xfrm>
+          <a:prstGeom prst="rect">
+            <a:avLst/>
+          </a:prstGeom>
+          <a:solidFill>
+            <a:srgbClr val="FDB515"/>
+          </a:solidFill>
+          <a:ln>
+            <a:noFill/>
+          </a:ln>
+          <a:effectLst/>
+        </p:spPr>
+        <p:style>
+          <a:lnRef idx="1">
+            <a:schemeClr val="accent1"/>
+          </a:lnRef>
+          <a:fillRef idx="3">
+            <a:schemeClr val="accent1"/>
+          </a:fillRef>
+          <a:effectRef idx="2">
+            <a:schemeClr val="accent1"/>
+          </a:effectRef>
+          <a:fontRef idx="minor">
+            <a:schemeClr val="lt1"/>
+          </a:fontRef>
+        </p:style>
+        <p:txBody>
+          <a:bodyPr rtlCol="0" anchor="ctr"/>
+          <a:lstStyle/>
+          <a:p>
+            <a:pPr algn="ctr"/>
+          </a:p>
+        </p:txBody>
+      </p:sp>
+      <p:sp>
+        <p:nvSpPr>
+          <p:cNvPr id="20" name="TextBox 19"/>
+          <p:cNvSpPr txBox="1"/>
+          <p:nvPr/>
+        </p:nvSpPr>
+        <p:spPr>
+          <a:xfrm>
+            <a:off x="1097280" y="4654296"/>
+            <a:ext cx="4617720" cy="603503"/>
+          </a:xfrm>
+          <a:prstGeom prst="rect">
+            <a:avLst/>
+          </a:prstGeom>
+          <a:noFill/>
+        </p:spPr>
+        <p:txBody>
+          <a:bodyPr wrap="square" anchor="ctr" lIns="0" rIns="0" tIns="0" bIns="0">
+            <a:spAutoFit/>
+          </a:bodyPr>
+          <a:lstStyle/>
+          <a:p>
+            <a:pPr>
+              <a:spcAft>
+                <a:spcPts val="600"/>
+              </a:spcAft>
+            </a:pPr>
+            <a:r>
+              <a:rPr sz="1200" b="1" i="0">
+                <a:solidFill>
+                  <a:srgbClr val="FDB515"/>
+                </a:solidFill>
+                <a:latin typeface="Arial"/>
+              </a:rPr>
+              <a:t>FINANCE</a:t>
+            </a:r>
+          </a:p>
+          <a:p>
+            <a:pPr>
+              <a:lnSpc>
+                <a:spcPct val="110000"/>
+              </a:lnSpc>
+            </a:pPr>
+            <a:r>
+              <a:rPr sz="1450" b="0" i="1">
+                <a:solidFill>
+                  <a:srgbClr val="FFFFFF"/>
+                </a:solidFill>
+                <a:latin typeface="Arial"/>
+              </a:rPr>
+              <a:t>“Will Microsoft stock increase by August 2026?” — plus ETF analysis.</a:t>
+            </a:r>
+          </a:p>
+        </p:txBody>
+      </p:sp>
+      <p:sp>
+        <p:nvSpPr>
+          <p:cNvPr id="21" name="Rectangle 20"/>
+          <p:cNvSpPr/>
+          <p:nvPr/>
+        </p:nvSpPr>
+        <p:spPr>
+          <a:xfrm>
+            <a:off x="6172200" y="4453128"/>
+            <a:ext cx="5166360" cy="914400"/>
+          </a:xfrm>
+          <a:prstGeom prst="rect">
+            <a:avLst/>
+          </a:prstGeom>
+          <a:solidFill>
+            <a:srgbClr val="003262"/>
+          </a:solidFill>
+          <a:ln>
+            <a:noFill/>
+          </a:ln>
+          <a:effectLst/>
+        </p:spPr>
+        <p:style>
+          <a:lnRef idx="1">
+            <a:schemeClr val="accent1"/>
+          </a:lnRef>
+          <a:fillRef idx="3">
+            <a:schemeClr val="accent1"/>
+          </a:fillRef>
+          <a:effectRef idx="2">
+            <a:schemeClr val="accent1"/>
+          </a:effectRef>
+          <a:fontRef idx="minor">
+            <a:schemeClr val="lt1"/>
+          </a:fontRef>
+        </p:style>
+        <p:txBody>
+          <a:bodyPr rtlCol="0" anchor="ctr"/>
+          <a:lstStyle/>
+          <a:p>
+            <a:pPr algn="ctr"/>
+          </a:p>
+        </p:txBody>
+      </p:sp>
+      <p:sp>
+        <p:nvSpPr>
+          <p:cNvPr id="22" name="Rectangle 21"/>
+          <p:cNvSpPr/>
+          <p:nvPr/>
+        </p:nvSpPr>
+        <p:spPr>
+          <a:xfrm>
+            <a:off x="6172200" y="4453128"/>
+            <a:ext cx="5166360" cy="91440"/>
+          </a:xfrm>
+          <a:prstGeom prst="rect">
+            <a:avLst/>
+          </a:prstGeom>
+          <a:solidFill>
+            <a:srgbClr val="FDB515"/>
+          </a:solidFill>
+          <a:ln>
+            <a:noFill/>
+          </a:ln>
+          <a:effectLst/>
+        </p:spPr>
+        <p:style>
+          <a:lnRef idx="1">
+            <a:schemeClr val="accent1"/>
+          </a:lnRef>
+          <a:fillRef idx="3">
+            <a:schemeClr val="accent1"/>
+          </a:fillRef>
+          <a:effectRef idx="2">
+            <a:schemeClr val="accent1"/>
+          </a:effectRef>
+          <a:fontRef idx="minor">
+            <a:schemeClr val="lt1"/>
+          </a:fontRef>
+        </p:style>
+        <p:txBody>
+          <a:bodyPr rtlCol="0" anchor="ctr"/>
+          <a:lstStyle/>
+          <a:p>
+            <a:pPr algn="ctr"/>
+          </a:p>
+        </p:txBody>
+      </p:sp>
+      <p:sp>
+        <p:nvSpPr>
+          <p:cNvPr id="23" name="TextBox 22"/>
+          <p:cNvSpPr txBox="1"/>
+          <p:nvPr/>
+        </p:nvSpPr>
+        <p:spPr>
+          <a:xfrm>
+            <a:off x="6446520" y="4654296"/>
+            <a:ext cx="4617720" cy="603503"/>
+          </a:xfrm>
+          <a:prstGeom prst="rect">
+            <a:avLst/>
+          </a:prstGeom>
+          <a:noFill/>
+        </p:spPr>
+        <p:txBody>
+          <a:bodyPr wrap="square" anchor="ctr" lIns="0" rIns="0" tIns="0" bIns="0">
+            <a:spAutoFit/>
+          </a:bodyPr>
+          <a:lstStyle/>
+          <a:p>
+            <a:pPr>
+              <a:spcAft>
+                <a:spcPts val="600"/>
+              </a:spcAft>
+            </a:pPr>
+            <a:r>
+              <a:rPr sz="1200" b="1" i="0">
+                <a:solidFill>
+                  <a:srgbClr val="FDB515"/>
+                </a:solidFill>
+                <a:latin typeface="Arial"/>
+              </a:rPr>
+              <a:t>COMMUNICATION</a:t>
+            </a:r>
+          </a:p>
+          <a:p>
+            <a:pPr>
+              <a:lnSpc>
+                <a:spcPct val="110000"/>
+              </a:lnSpc>
+            </a:pPr>
+            <a:r>
+              <a:rPr sz="1450" b="0" i="1">
+                <a:solidFill>
+                  <a:srgbClr val="FFFFFF"/>
+                </a:solidFill>
+                <a:latin typeface="Arial"/>
+              </a:rPr>
+              <a:t>Slack, iMessage, and Gmail messages — sent through third-party agents.</a:t>
+            </a:r>
+          </a:p>
+        </p:txBody>
+      </p:sp>
+      <p:sp>
+        <p:nvSpPr>
+          <p:cNvPr id="24" name="Rectangle 23"/>
+          <p:cNvSpPr/>
+          <p:nvPr/>
+        </p:nvSpPr>
+        <p:spPr>
+          <a:xfrm>
+            <a:off x="822960" y="5490972"/>
+            <a:ext cx="5166360" cy="914400"/>
+          </a:xfrm>
+          <a:prstGeom prst="rect">
+            <a:avLst/>
+          </a:prstGeom>
+          <a:solidFill>
+            <a:srgbClr val="003262"/>
+          </a:solidFill>
+          <a:ln>
+            <a:noFill/>
+          </a:ln>
+          <a:effectLst/>
+        </p:spPr>
+        <p:style>
+          <a:lnRef idx="1">
+            <a:schemeClr val="accent1"/>
+          </a:lnRef>
+          <a:fillRef idx="3">
+            <a:schemeClr val="accent1"/>
+          </a:fillRef>
+          <a:effectRef idx="2">
+            <a:schemeClr val="accent1"/>
+          </a:effectRef>
+          <a:fontRef idx="minor">
+            <a:schemeClr val="lt1"/>
+          </a:fontRef>
+        </p:style>
+        <p:txBody>
+          <a:bodyPr rtlCol="0" anchor="ctr"/>
+          <a:lstStyle/>
+          <a:p>
+            <a:pPr algn="ctr"/>
+          </a:p>
+        </p:txBody>
+      </p:sp>
+      <p:sp>
+        <p:nvSpPr>
+          <p:cNvPr id="25" name="Rectangle 24"/>
+          <p:cNvSpPr/>
+          <p:nvPr/>
+        </p:nvSpPr>
+        <p:spPr>
+          <a:xfrm>
+            <a:off x="822960" y="5490972"/>
+            <a:ext cx="5166360" cy="91440"/>
+          </a:xfrm>
+          <a:prstGeom prst="rect">
+            <a:avLst/>
+          </a:prstGeom>
+          <a:solidFill>
+            <a:srgbClr val="FDB515"/>
+          </a:solidFill>
+          <a:ln>
+            <a:noFill/>
+          </a:ln>
+          <a:effectLst/>
+        </p:spPr>
+        <p:style>
+          <a:lnRef idx="1">
+            <a:schemeClr val="accent1"/>
+          </a:lnRef>
+          <a:fillRef idx="3">
+            <a:schemeClr val="accent1"/>
+          </a:fillRef>
+          <a:effectRef idx="2">
+            <a:schemeClr val="accent1"/>
+          </a:effectRef>
+          <a:fontRef idx="minor">
+            <a:schemeClr val="lt1"/>
+          </a:fontRef>
+        </p:style>
+        <p:txBody>
+          <a:bodyPr rtlCol="0" anchor="ctr"/>
+          <a:lstStyle/>
+          <a:p>
+            <a:pPr algn="ctr"/>
+          </a:p>
+        </p:txBody>
+      </p:sp>
+      <p:sp>
+        <p:nvSpPr>
+          <p:cNvPr id="26" name="TextBox 25"/>
+          <p:cNvSpPr txBox="1"/>
+          <p:nvPr/>
+        </p:nvSpPr>
+        <p:spPr>
+          <a:xfrm>
+            <a:off x="1097280" y="5692140"/>
+            <a:ext cx="4617720" cy="603503"/>
+          </a:xfrm>
+          <a:prstGeom prst="rect">
+            <a:avLst/>
+          </a:prstGeom>
+          <a:noFill/>
+        </p:spPr>
+        <p:txBody>
+          <a:bodyPr wrap="square" anchor="ctr" lIns="0" rIns="0" tIns="0" bIns="0">
+            <a:spAutoFit/>
+          </a:bodyPr>
+          <a:lstStyle/>
+          <a:p>
+            <a:pPr>
+              <a:spcAft>
+                <a:spcPts val="600"/>
+              </a:spcAft>
+            </a:pPr>
+            <a:r>
+              <a:rPr sz="1200" b="1" i="0">
+                <a:solidFill>
+                  <a:srgbClr val="FDB515"/>
+                </a:solidFill>
+                <a:latin typeface="Arial"/>
+              </a:rPr>
+              <a:t>SELF-SETUP</a:t>
+            </a:r>
+          </a:p>
+          <a:p>
+            <a:pPr>
+              <a:lnSpc>
+                <a:spcPct val="110000"/>
+              </a:lnSpc>
+            </a:pPr>
+            <a:r>
+              <a:rPr sz="1450" b="0" i="1">
+                <a:solidFill>
+                  <a:srgbClr val="FFFFFF"/>
+                </a:solidFill>
+                <a:latin typeface="Arial"/>
+              </a:rPr>
+              <a:t>“Authenticate with govee.com so you can control the lights.”</a:t>
+            </a:r>
+          </a:p>
+        </p:txBody>
+      </p:sp>
+      <p:sp>
+        <p:nvSpPr>
+          <p:cNvPr id="27" name="Rectangle 26"/>
+          <p:cNvSpPr/>
+          <p:nvPr/>
+        </p:nvSpPr>
+        <p:spPr>
+          <a:xfrm>
+            <a:off x="6172200" y="5490972"/>
+            <a:ext cx="5166360" cy="914400"/>
+          </a:xfrm>
+          <a:prstGeom prst="rect">
+            <a:avLst/>
+          </a:prstGeom>
+          <a:solidFill>
+            <a:srgbClr val="003262"/>
+          </a:solidFill>
+          <a:ln>
+            <a:noFill/>
+          </a:ln>
+          <a:effectLst/>
+        </p:spPr>
+        <p:style>
+          <a:lnRef idx="1">
+            <a:schemeClr val="accent1"/>
+          </a:lnRef>
+          <a:fillRef idx="3">
+            <a:schemeClr val="accent1"/>
+          </a:fillRef>
+          <a:effectRef idx="2">
+            <a:schemeClr val="accent1"/>
+          </a:effectRef>
+          <a:fontRef idx="minor">
+            <a:schemeClr val="lt1"/>
+          </a:fontRef>
+        </p:style>
+        <p:txBody>
+          <a:bodyPr rtlCol="0" anchor="ctr"/>
+          <a:lstStyle/>
+          <a:p>
+            <a:pPr algn="ctr"/>
+          </a:p>
+        </p:txBody>
+      </p:sp>
+      <p:sp>
+        <p:nvSpPr>
+          <p:cNvPr id="28" name="Rectangle 27"/>
+          <p:cNvSpPr/>
+          <p:nvPr/>
+        </p:nvSpPr>
+        <p:spPr>
+          <a:xfrm>
+            <a:off x="6172200" y="5490972"/>
+            <a:ext cx="5166360" cy="91440"/>
+          </a:xfrm>
+          <a:prstGeom prst="rect">
+            <a:avLst/>
+          </a:prstGeom>
+          <a:solidFill>
+            <a:srgbClr val="FDB515"/>
+          </a:solidFill>
+          <a:ln>
+            <a:noFill/>
+          </a:ln>
+          <a:effectLst/>
+        </p:spPr>
+        <p:style>
+          <a:lnRef idx="1">
+            <a:schemeClr val="accent1"/>
+          </a:lnRef>
+          <a:fillRef idx="3">
+            <a:schemeClr val="accent1"/>
+          </a:fillRef>
+          <a:effectRef idx="2">
+            <a:schemeClr val="accent1"/>
+          </a:effectRef>
+          <a:fontRef idx="minor">
+            <a:schemeClr val="lt1"/>
+          </a:fontRef>
+        </p:style>
+        <p:txBody>
+          <a:bodyPr rtlCol="0" anchor="ctr"/>
+          <a:lstStyle/>
+          <a:p>
+            <a:pPr algn="ctr"/>
+          </a:p>
+        </p:txBody>
+      </p:sp>
+      <p:sp>
+        <p:nvSpPr>
+          <p:cNvPr id="29" name="TextBox 28"/>
+          <p:cNvSpPr txBox="1"/>
+          <p:nvPr/>
+        </p:nvSpPr>
+        <p:spPr>
+          <a:xfrm>
+            <a:off x="6446520" y="5692140"/>
+            <a:ext cx="4617720" cy="603503"/>
+          </a:xfrm>
+          <a:prstGeom prst="rect">
+            <a:avLst/>
+          </a:prstGeom>
+          <a:noFill/>
+        </p:spPr>
+        <p:txBody>
+          <a:bodyPr wrap="square" anchor="ctr" lIns="0" rIns="0" tIns="0" bIns="0">
+            <a:spAutoFit/>
+          </a:bodyPr>
+          <a:lstStyle/>
+          <a:p>
+            <a:pPr>
+              <a:spcAft>
+                <a:spcPts val="600"/>
+              </a:spcAft>
+            </a:pPr>
+            <a:r>
+              <a:rPr sz="1200" b="1" i="0">
+                <a:solidFill>
+                  <a:srgbClr val="FDB515"/>
+                </a:solidFill>
+                <a:latin typeface="Arial"/>
+              </a:rPr>
+              <a:t>ETHICAL REFUSAL</a:t>
+            </a:r>
+          </a:p>
+          <a:p>
+            <a:pPr>
+              <a:lnSpc>
+                <a:spcPct val="110000"/>
+              </a:lnSpc>
+            </a:pPr>
+            <a:r>
+              <a:rPr sz="1450" b="0" i="1">
+                <a:solidFill>
+                  <a:srgbClr val="FFFFFF"/>
+                </a:solidFill>
+                <a:latin typeface="Arial"/>
+              </a:rPr>
+              <a:t>An unethical hacking request — refused, with five legitimate alternatives.</a:t>
+            </a:r>
+          </a:p>
+        </p:txBody>
+      </p:sp>
+      <p:sp>
+        <p:nvSpPr>
+          <p:cNvPr id="30" name="Rectangle 29"/>
+          <p:cNvSpPr/>
+          <p:nvPr/>
+        </p:nvSpPr>
+        <p:spPr>
+          <a:xfrm>
+            <a:off x="0" y="6510528"/>
+            <a:ext cx="12188952" cy="27432"/>
+          </a:xfrm>
+          <a:prstGeom prst="rect">
+            <a:avLst/>
+          </a:prstGeom>
+          <a:solidFill>
+            <a:srgbClr val="E9E5D8"/>
+          </a:solidFill>
+          <a:ln>
+            <a:noFill/>
+          </a:ln>
+          <a:effectLst/>
+        </p:spPr>
+        <p:style>
+          <a:lnRef idx="1">
+            <a:schemeClr val="accent1"/>
+          </a:lnRef>
+          <a:fillRef idx="3">
+            <a:schemeClr val="accent1"/>
+          </a:fillRef>
+          <a:effectRef idx="2">
+            <a:schemeClr val="accent1"/>
+          </a:effectRef>
+          <a:fontRef idx="minor">
+            <a:schemeClr val="lt1"/>
+          </a:fontRef>
+        </p:style>
+        <p:txBody>
+          <a:bodyPr rtlCol="0" anchor="ctr"/>
+          <a:lstStyle/>
+          <a:p>
+            <a:pPr algn="ctr"/>
+          </a:p>
+        </p:txBody>
+      </p:sp>
+      <p:sp>
+        <p:nvSpPr>
+          <p:cNvPr id="31" name="TextBox 30"/>
+          <p:cNvSpPr txBox="1"/>
+          <p:nvPr/>
+        </p:nvSpPr>
+        <p:spPr>
+          <a:xfrm>
+            <a:off x="822960" y="6547104"/>
+            <a:ext cx="8229600" cy="274320"/>
+          </a:xfrm>
+          <a:prstGeom prst="rect">
+            <a:avLst/>
+          </a:prstGeom>
+          <a:noFill/>
+        </p:spPr>
+        <p:txBody>
+          <a:bodyPr wrap="square" anchor="t" lIns="0" rIns="0" tIns="0" bIns="0">
+            <a:spAutoFit/>
+          </a:bodyPr>
+          <a:lstStyle/>
+          <a:p>
+            <a:r>
+              <a:rPr sz="1100" b="0" i="0">
+                <a:solidFill>
+                  <a:srgbClr val="4A5260"/>
+                </a:solidFill>
+                <a:latin typeface="Arial"/>
+              </a:rPr>
+              <a:t>KISS Sorcar  ·  K. Sen, UC Berkeley</a:t>
+            </a:r>
+          </a:p>
+        </p:txBody>
+      </p:sp>
+      <p:sp>
+        <p:nvSpPr>
+          <p:cNvPr id="32" name="TextBox 31"/>
+          <p:cNvSpPr txBox="1"/>
+          <p:nvPr/>
+        </p:nvSpPr>
+        <p:spPr>
+          <a:xfrm>
+            <a:off x="10058400" y="6547104"/>
+            <a:ext cx="1307592" cy="274320"/>
+          </a:xfrm>
+          <a:prstGeom prst="rect">
+            <a:avLst/>
+          </a:prstGeom>
+          <a:noFill/>
+        </p:spPr>
+        <p:txBody>
+          <a:bodyPr wrap="square" anchor="t" lIns="0" rIns="0" tIns="0" bIns="0">
+            <a:spAutoFit/>
+          </a:bodyPr>
+          <a:lstStyle/>
+          <a:p>
+            <a:pPr algn="r"/>
+            <a:r>
+              <a:rPr sz="1100" b="1" i="0">
+                <a:solidFill>
+                  <a:srgbClr val="C88A00"/>
+                </a:solidFill>
+                <a:latin typeface="Arial"/>
+              </a:rPr>
+              <a:t>16</a:t>
             </a:r>
           </a:p>
         </p:txBody>

</xml_diff>

<commit_message>
docs: update SE Kiss Sorcar presentation slides
</commit_message>
<xml_diff>
--- a/papers/sekisssorcar/se_kiss_sorcar_slides.pptx
+++ b/papers/sekisssorcar/se_kiss_sorcar_slides.pptx
@@ -3908,6 +3908,36 @@
           </a:prstGeom>
         </p:spPr>
       </p:pic>
+      <p:pic>
+        <p:nvPicPr>
+          <p:cNvPr id="9" name="Picture 8" descr="A QR Code">
+            <a:extLst>
+              <a:ext uri="{FF2B5EF4-FFF2-40B4-BE49-F238E27FC236}">
+                <a16:creationId xmlns:a16="http://schemas.microsoft.com/office/drawing/2014/main" id="{5EE03E55-29EA-69BD-29ED-9B5D04212B9C}"/>
+              </a:ext>
+            </a:extLst>
+          </p:cNvPr>
+          <p:cNvPicPr>
+            <a:picLocks noChangeAspect="1"/>
+          </p:cNvPicPr>
+          <p:nvPr/>
+        </p:nvPicPr>
+        <p:blipFill>
+          <a:blip r:embed="rId3"/>
+          <a:stretch>
+            <a:fillRect/>
+          </a:stretch>
+        </p:blipFill>
+        <p:spPr>
+          <a:xfrm>
+            <a:off x="10490200" y="2240280"/>
+            <a:ext cx="1503680" cy="1503680"/>
+          </a:xfrm>
+          <a:prstGeom prst="rect">
+            <a:avLst/>
+          </a:prstGeom>
+        </p:spPr>
+      </p:pic>
     </p:spTree>
   </p:cSld>
   <p:clrMapOvr>
@@ -5887,14 +5917,6 @@
 <file path=ppt/slides/slide13.xml><?xml version="1.0" encoding="utf-8"?>
 <p:sld xmlns:a="http://schemas.openxmlformats.org/drawingml/2006/main" xmlns:r="http://schemas.openxmlformats.org/officeDocument/2006/relationships" xmlns:p="http://schemas.openxmlformats.org/presentationml/2006/main">
   <p:cSld>
-    <p:bg>
-      <p:bgPr>
-        <a:solidFill>
-          <a:srgbClr val="F7F5EF"/>
-        </a:solidFill>
-        <a:effectLst/>
-      </p:bgPr>
-    </p:bg>
     <p:spTree>
       <p:nvGrpSpPr>
         <p:cNvPr id="1" name=""/>
@@ -6313,6 +6335,11 @@
         </p:txBody>
       </p:sp>
     </p:spTree>
+    <p:extLst>
+      <p:ext uri="{BB962C8B-B14F-4D97-AF65-F5344CB8AC3E}">
+        <p14:creationId xmlns:p14="http://schemas.microsoft.com/office/powerpoint/2010/main" val="2879443887"/>
+      </p:ext>
+    </p:extLst>
   </p:cSld>
   <p:clrMapOvr>
     <a:masterClrMapping/>
@@ -6323,14 +6350,6 @@
 <file path=ppt/slides/slide14.xml><?xml version="1.0" encoding="utf-8"?>
 <p:sld xmlns:a="http://schemas.openxmlformats.org/drawingml/2006/main" xmlns:r="http://schemas.openxmlformats.org/officeDocument/2006/relationships" xmlns:p="http://schemas.openxmlformats.org/presentationml/2006/main">
   <p:cSld>
-    <p:bg>
-      <p:bgPr>
-        <a:solidFill>
-          <a:srgbClr val="F7F5EF"/>
-        </a:solidFill>
-        <a:effectLst/>
-      </p:bgPr>
-    </p:bg>
     <p:spTree>
       <p:nvGrpSpPr>
         <p:cNvPr id="1" name=""/>
@@ -6697,6 +6716,11 @@
         </p:txBody>
       </p:sp>
     </p:spTree>
+    <p:extLst>
+      <p:ext uri="{BB962C8B-B14F-4D97-AF65-F5344CB8AC3E}">
+        <p14:creationId xmlns:p14="http://schemas.microsoft.com/office/powerpoint/2010/main" val="389597333"/>
+      </p:ext>
+    </p:extLst>
   </p:cSld>
   <p:clrMapOvr>
     <a:masterClrMapping/>
@@ -21034,6 +21058,36 @@
           </a:p>
         </p:txBody>
       </p:sp>
+      <p:pic>
+        <p:nvPicPr>
+          <p:cNvPr id="7" name="Picture 6" descr="A QR Code">
+            <a:extLst>
+              <a:ext uri="{FF2B5EF4-FFF2-40B4-BE49-F238E27FC236}">
+                <a16:creationId xmlns:a16="http://schemas.microsoft.com/office/drawing/2014/main" id="{06955F7C-3B70-51DF-76F4-B154AEE9E2DF}"/>
+              </a:ext>
+            </a:extLst>
+          </p:cNvPr>
+          <p:cNvPicPr>
+            <a:picLocks noChangeAspect="1"/>
+          </p:cNvPicPr>
+          <p:nvPr/>
+        </p:nvPicPr>
+        <p:blipFill>
+          <a:blip r:embed="rId3"/>
+          <a:stretch>
+            <a:fillRect/>
+          </a:stretch>
+        </p:blipFill>
+        <p:spPr>
+          <a:xfrm>
+            <a:off x="10567939" y="114560"/>
+            <a:ext cx="1531359" cy="1531359"/>
+          </a:xfrm>
+          <a:prstGeom prst="rect">
+            <a:avLst/>
+          </a:prstGeom>
+        </p:spPr>
+      </p:pic>
     </p:spTree>
   </p:cSld>
   <p:clrMapOvr>

</xml_diff>